<commit_message>
Scott live: Scott's photo and profile, a calmer challenge stage
Slide 2 now has Scott's photo (cropped from the Meet screenshot to his
tile only), Canada → US flags and his profile in English with Japanese
underneath: born in Canada and grew up mostly in the US, came to Japan
for martial arts and 整体, teaching for over 35 years, lives in Osaka,
YouTube BananaeigoTV.

The challenge slides drop the stars and sparkles, tone down the
sunburst, and title in Japanese (チャレンジステージ / チャレンジタイム) in
Reggae One with a dark drop shadow. Reggae One is added to the shared
fonts as a kana and ASCII subset, and the .pptx keeps it for Japanese
text instead of switching to Noto Sans JP.

Co-Authored-By: Claude Opus 5.5 <noreply@anthropic.com>
Claude-Session: https://claude.ai/code/session_0167kk19fU69KXrDnUiK9iq6
</commit_message>
<xml_diff>
--- a/live/scott-will-can/scott-will-can.pptx
+++ b/live/scott-will-can/scott-will-can.pptx
@@ -12861,7 +12861,7 @@
             </a:pathLst>
           </a:custGeom>
           <a:solidFill>
-            <a:srgbClr val="F36B3D"/>
+            <a:srgbClr val="F25F2D"/>
           </a:solidFill>
           <a:ln/>
         </p:spPr>
@@ -13052,7 +13052,7 @@
             </a:avLst>
           </a:prstGeom>
           <a:solidFill>
-            <a:srgbClr val="FFD966"/>
+            <a:srgbClr val="FFFFFF"/>
           </a:solidFill>
           <a:ln/>
         </p:spPr>
@@ -13082,7 +13082,7 @@
             <a:r>
               <a:rPr sz="1500" b="1">
                 <a:solidFill>
-                  <a:srgbClr val="1A2238"/>
+                  <a:srgbClr val="C23B12"/>
                 </a:solidFill>
                 <a:latin typeface="Noto Sans JP"/>
                 <a:ea typeface="Noto Sans JP"/>
@@ -13100,53 +13100,77 @@
         </p:nvSpPr>
         <p:spPr>
           <a:xfrm>
-            <a:off x="609600" y="1343025"/>
-            <a:ext cx="7286625" cy="942975"/>
-          </a:xfrm>
-          <a:prstGeom prst="rect">
-            <a:avLst/>
-          </a:prstGeom>
-          <a:noFill/>
-          <a:ln/>
-        </p:spPr>
-        <p:txBody>
-          <a:bodyPr wrap="square" lIns="0" tIns="0" rIns="0" bIns="0" anchor="ctr"/>
-          <a:lstStyle/>
-          <a:p>
-            <a:pPr/>
-            <a:r>
-              <a:rPr sz="5700" b="1" spc="-75" kern="0">
+            <a:off x="676275" y="1352550"/>
+            <a:ext cx="8401050" cy="1266825"/>
+          </a:xfrm>
+          <a:prstGeom prst="rect">
+            <a:avLst/>
+          </a:prstGeom>
+          <a:noFill/>
+          <a:ln/>
+        </p:spPr>
+        <p:txBody>
+          <a:bodyPr wrap="square" lIns="0" tIns="0" rIns="0" bIns="0" anchor="ctr"/>
+          <a:lstStyle/>
+          <a:p>
+            <a:pPr/>
+            <a:r>
+              <a:rPr sz="6900">
+                <a:solidFill>
+                  <a:srgbClr val="A3300B"/>
+                </a:solidFill>
+                <a:latin typeface="Reggae One"/>
+                <a:ea typeface="Reggae One"/>
+              </a:rPr>
+              <a:t>チャレンジタイム</a:t>
+            </a:r>
+          </a:p>
+        </p:txBody>
+      </p:sp>
+      <p:sp>
+        <p:nvSpPr>
+          <p:cNvPr id="12" name=""/>
+          <p:cNvSpPr txBox="1"/>
+          <p:nvPr/>
+        </p:nvSpPr>
+        <p:spPr>
+          <a:xfrm>
+            <a:off x="609600" y="1285875"/>
+            <a:ext cx="8401050" cy="1266825"/>
+          </a:xfrm>
+          <a:prstGeom prst="rect">
+            <a:avLst/>
+          </a:prstGeom>
+          <a:noFill/>
+          <a:ln/>
+        </p:spPr>
+        <p:txBody>
+          <a:bodyPr wrap="square" lIns="0" tIns="0" rIns="0" bIns="0" anchor="ctr"/>
+          <a:lstStyle/>
+          <a:p>
+            <a:pPr/>
+            <a:r>
+              <a:rPr sz="6900">
                 <a:solidFill>
                   <a:srgbClr val="FFFFFF"/>
                 </a:solidFill>
-                <a:latin typeface="DM Sans"/>
-                <a:ea typeface="DM Sans"/>
-              </a:rPr>
-              <a:t>CHALLENGE </a:t>
-            </a:r>
-            <a:pPr/>
-            <a:r>
-              <a:rPr sz="5700" b="1" spc="-75" kern="0">
-                <a:solidFill>
-                  <a:srgbClr val="FFD966"/>
-                </a:solidFill>
-                <a:latin typeface="DM Sans"/>
-                <a:ea typeface="DM Sans"/>
-              </a:rPr>
-              <a:t>TIME</a:t>
-            </a:r>
-          </a:p>
-        </p:txBody>
-      </p:sp>
-      <p:sp>
-        <p:nvSpPr>
-          <p:cNvPr id="12" name=""/>
-          <p:cNvSpPr/>
-          <p:nvPr/>
-        </p:nvSpPr>
-        <p:spPr>
-          <a:xfrm>
-            <a:off x="609600" y="2943225"/>
+                <a:latin typeface="Reggae One"/>
+                <a:ea typeface="Reggae One"/>
+              </a:rPr>
+              <a:t>チャレンジタイム</a:t>
+            </a:r>
+          </a:p>
+        </p:txBody>
+      </p:sp>
+      <p:sp>
+        <p:nvSpPr>
+          <p:cNvPr id="13" name=""/>
+          <p:cNvSpPr/>
+          <p:nvPr/>
+        </p:nvSpPr>
+        <p:spPr>
+          <a:xfrm>
+            <a:off x="609600" y="3105150"/>
             <a:ext cx="7658100" cy="2028825"/>
           </a:xfrm>
           <a:prstGeom prst="roundRect">
@@ -13169,13 +13193,13 @@
       </p:sp>
       <p:sp>
         <p:nvSpPr>
-          <p:cNvPr id="13" name=""/>
-          <p:cNvSpPr txBox="1"/>
-          <p:nvPr/>
-        </p:nvSpPr>
-        <p:spPr>
-          <a:xfrm>
-            <a:off x="933450" y="3152775"/>
+          <p:cNvPr id="14" name=""/>
+          <p:cNvSpPr txBox="1"/>
+          <p:nvPr/>
+        </p:nvSpPr>
+        <p:spPr>
+          <a:xfrm>
+            <a:off x="933450" y="3314700"/>
             <a:ext cx="1362075" cy="171450"/>
           </a:xfrm>
           <a:prstGeom prst="rect">
@@ -13204,13 +13228,13 @@
       </p:sp>
       <p:sp>
         <p:nvSpPr>
-          <p:cNvPr id="14" name=""/>
-          <p:cNvSpPr txBox="1"/>
-          <p:nvPr/>
-        </p:nvSpPr>
-        <p:spPr>
-          <a:xfrm>
-            <a:off x="933450" y="3381375"/>
+          <p:cNvPr id="15" name=""/>
+          <p:cNvSpPr txBox="1"/>
+          <p:nvPr/>
+        </p:nvSpPr>
+        <p:spPr>
+          <a:xfrm>
+            <a:off x="933450" y="3543300"/>
             <a:ext cx="6438900" cy="523875"/>
           </a:xfrm>
           <a:prstGeom prst="rect">
@@ -13261,13 +13285,13 @@
       </p:sp>
       <p:sp>
         <p:nvSpPr>
-          <p:cNvPr id="15" name=""/>
-          <p:cNvSpPr txBox="1"/>
-          <p:nvPr/>
-        </p:nvSpPr>
-        <p:spPr>
-          <a:xfrm>
-            <a:off x="933450" y="3924300"/>
+          <p:cNvPr id="16" name=""/>
+          <p:cNvSpPr txBox="1"/>
+          <p:nvPr/>
+        </p:nvSpPr>
+        <p:spPr>
+          <a:xfrm>
+            <a:off x="933450" y="4086225"/>
             <a:ext cx="2095500" cy="276225"/>
           </a:xfrm>
           <a:prstGeom prst="rect">
@@ -13296,13 +13320,13 @@
       </p:sp>
       <p:sp>
         <p:nvSpPr>
-          <p:cNvPr id="16" name=""/>
-          <p:cNvSpPr/>
-          <p:nvPr/>
-        </p:nvSpPr>
-        <p:spPr>
-          <a:xfrm>
-            <a:off x="933450" y="4352925"/>
+          <p:cNvPr id="17" name=""/>
+          <p:cNvSpPr/>
+          <p:nvPr/>
+        </p:nvSpPr>
+        <p:spPr>
+          <a:xfrm>
+            <a:off x="933450" y="4514850"/>
             <a:ext cx="1066800" cy="371475"/>
           </a:xfrm>
           <a:prstGeom prst="roundRect">
@@ -13318,13 +13342,13 @@
       </p:sp>
       <p:sp>
         <p:nvSpPr>
-          <p:cNvPr id="17" name=""/>
-          <p:cNvSpPr txBox="1"/>
-          <p:nvPr/>
-        </p:nvSpPr>
-        <p:spPr>
-          <a:xfrm>
-            <a:off x="1085850" y="4410075"/>
+          <p:cNvPr id="18" name=""/>
+          <p:cNvSpPr txBox="1"/>
+          <p:nvPr/>
+        </p:nvSpPr>
+        <p:spPr>
+          <a:xfrm>
+            <a:off x="1085850" y="4572000"/>
             <a:ext cx="1219200" cy="247650"/>
           </a:xfrm>
           <a:prstGeom prst="rect">
@@ -13353,13 +13377,13 @@
       </p:sp>
       <p:sp>
         <p:nvSpPr>
-          <p:cNvPr id="18" name=""/>
-          <p:cNvSpPr/>
-          <p:nvPr/>
-        </p:nvSpPr>
-        <p:spPr>
-          <a:xfrm>
-            <a:off x="2095500" y="4352925"/>
+          <p:cNvPr id="19" name=""/>
+          <p:cNvSpPr/>
+          <p:nvPr/>
+        </p:nvSpPr>
+        <p:spPr>
+          <a:xfrm>
+            <a:off x="2095500" y="4514850"/>
             <a:ext cx="1066800" cy="371475"/>
           </a:xfrm>
           <a:prstGeom prst="roundRect">
@@ -13375,13 +13399,13 @@
       </p:sp>
       <p:sp>
         <p:nvSpPr>
-          <p:cNvPr id="19" name=""/>
-          <p:cNvSpPr txBox="1"/>
-          <p:nvPr/>
-        </p:nvSpPr>
-        <p:spPr>
-          <a:xfrm>
-            <a:off x="2247900" y="4410075"/>
+          <p:cNvPr id="20" name=""/>
+          <p:cNvSpPr txBox="1"/>
+          <p:nvPr/>
+        </p:nvSpPr>
+        <p:spPr>
+          <a:xfrm>
+            <a:off x="2247900" y="4572000"/>
             <a:ext cx="1219200" cy="247650"/>
           </a:xfrm>
           <a:prstGeom prst="rect">
@@ -13410,13 +13434,13 @@
       </p:sp>
       <p:sp>
         <p:nvSpPr>
-          <p:cNvPr id="20" name=""/>
-          <p:cNvSpPr/>
-          <p:nvPr/>
-        </p:nvSpPr>
-        <p:spPr>
-          <a:xfrm>
-            <a:off x="3257550" y="4352925"/>
+          <p:cNvPr id="21" name=""/>
+          <p:cNvSpPr/>
+          <p:nvPr/>
+        </p:nvSpPr>
+        <p:spPr>
+          <a:xfrm>
+            <a:off x="3257550" y="4514850"/>
             <a:ext cx="1104900" cy="371475"/>
           </a:xfrm>
           <a:prstGeom prst="roundRect">
@@ -13432,13 +13456,13 @@
       </p:sp>
       <p:sp>
         <p:nvSpPr>
-          <p:cNvPr id="21" name=""/>
-          <p:cNvSpPr txBox="1"/>
-          <p:nvPr/>
-        </p:nvSpPr>
-        <p:spPr>
-          <a:xfrm>
-            <a:off x="3409950" y="4410075"/>
+          <p:cNvPr id="22" name=""/>
+          <p:cNvSpPr txBox="1"/>
+          <p:nvPr/>
+        </p:nvSpPr>
+        <p:spPr>
+          <a:xfrm>
+            <a:off x="3409950" y="4572000"/>
             <a:ext cx="1266825" cy="247650"/>
           </a:xfrm>
           <a:prstGeom prst="rect">
@@ -13467,13 +13491,13 @@
       </p:sp>
       <p:sp>
         <p:nvSpPr>
-          <p:cNvPr id="22" name=""/>
-          <p:cNvSpPr/>
-          <p:nvPr/>
-        </p:nvSpPr>
-        <p:spPr>
-          <a:xfrm>
-            <a:off x="8867775" y="2667000"/>
+          <p:cNvPr id="23" name=""/>
+          <p:cNvSpPr/>
+          <p:nvPr/>
+        </p:nvSpPr>
+        <p:spPr>
+          <a:xfrm>
+            <a:off x="8867775" y="2838450"/>
             <a:ext cx="2571750" cy="2571750"/>
           </a:xfrm>
           <a:prstGeom prst="ellipse">
@@ -13484,7 +13508,7 @@
           </a:solidFill>
           <a:ln w="171450">
             <a:solidFill>
-              <a:srgbClr val="FFD966"/>
+              <a:srgbClr val="FFD3C2"/>
             </a:solidFill>
             <a:prstDash val="solid"/>
           </a:ln>
@@ -13499,13 +13523,13 @@
       </p:sp>
       <p:sp>
         <p:nvSpPr>
-          <p:cNvPr id="23" name=""/>
-          <p:cNvSpPr txBox="1"/>
-          <p:nvPr/>
-        </p:nvSpPr>
-        <p:spPr>
-          <a:xfrm>
-            <a:off x="9382125" y="3286125"/>
+          <p:cNvPr id="24" name=""/>
+          <p:cNvSpPr txBox="1"/>
+          <p:nvPr/>
+        </p:nvSpPr>
+        <p:spPr>
+          <a:xfrm>
+            <a:off x="9382125" y="3457575"/>
             <a:ext cx="2124075" cy="1038225"/>
           </a:xfrm>
           <a:prstGeom prst="rect">
@@ -13534,13 +13558,13 @@
       </p:sp>
       <p:sp>
         <p:nvSpPr>
-          <p:cNvPr id="24" name=""/>
-          <p:cNvSpPr txBox="1"/>
-          <p:nvPr/>
-        </p:nvSpPr>
-        <p:spPr>
-          <a:xfrm>
-            <a:off x="9725025" y="4305300"/>
+          <p:cNvPr id="25" name=""/>
+          <p:cNvSpPr txBox="1"/>
+          <p:nvPr/>
+        </p:nvSpPr>
+        <p:spPr>
+          <a:xfrm>
+            <a:off x="9725025" y="4476750"/>
             <a:ext cx="1323975" cy="190500"/>
           </a:xfrm>
           <a:prstGeom prst="rect">
@@ -13569,7 +13593,7 @@
       </p:sp>
       <p:sp>
         <p:nvSpPr>
-          <p:cNvPr id="25" name=""/>
+          <p:cNvPr id="26" name=""/>
           <p:cNvSpPr/>
           <p:nvPr/>
         </p:nvSpPr>
@@ -13591,7 +13615,7 @@
       </p:sp>
       <p:sp>
         <p:nvSpPr>
-          <p:cNvPr id="26" name=""/>
+          <p:cNvPr id="27" name=""/>
           <p:cNvSpPr/>
           <p:nvPr/>
         </p:nvSpPr>
@@ -13604,14 +13628,14 @@
             <a:avLst/>
           </a:prstGeom>
           <a:solidFill>
-            <a:srgbClr val="FFD966"/>
-          </a:solidFill>
-          <a:ln/>
-        </p:spPr>
-      </p:sp>
-      <p:sp>
-        <p:nvSpPr>
-          <p:cNvPr id="27" name=""/>
+            <a:srgbClr val="F0521E"/>
+          </a:solidFill>
+          <a:ln/>
+        </p:spPr>
+      </p:sp>
+      <p:sp>
+        <p:nvSpPr>
+          <p:cNvPr id="28" name=""/>
           <p:cNvSpPr txBox="1"/>
           <p:nvPr/>
         </p:nvSpPr>
@@ -13634,7 +13658,7 @@
             <a:r>
               <a:rPr sz="1350" b="1">
                 <a:solidFill>
-                  <a:srgbClr val="1A2238"/>
+                  <a:srgbClr val="FFFFFF"/>
                 </a:solidFill>
                 <a:latin typeface="DM Sans"/>
                 <a:ea typeface="DM Sans"/>
@@ -13646,7 +13670,7 @@
       </p:sp>
       <p:sp>
         <p:nvSpPr>
-          <p:cNvPr id="28" name=""/>
+          <p:cNvPr id="29" name=""/>
           <p:cNvSpPr txBox="1"/>
           <p:nvPr/>
         </p:nvSpPr>
@@ -13681,7 +13705,7 @@
       </p:sp>
       <p:sp>
         <p:nvSpPr>
-          <p:cNvPr id="29" name=""/>
+          <p:cNvPr id="30" name=""/>
           <p:cNvSpPr/>
           <p:nvPr/>
         </p:nvSpPr>
@@ -13703,7 +13727,7 @@
       </p:sp>
       <p:sp>
         <p:nvSpPr>
-          <p:cNvPr id="30" name=""/>
+          <p:cNvPr id="31" name=""/>
           <p:cNvSpPr/>
           <p:nvPr/>
         </p:nvSpPr>
@@ -13716,14 +13740,14 @@
             <a:avLst/>
           </a:prstGeom>
           <a:solidFill>
-            <a:srgbClr val="FFD966"/>
-          </a:solidFill>
-          <a:ln/>
-        </p:spPr>
-      </p:sp>
-      <p:sp>
-        <p:nvSpPr>
-          <p:cNvPr id="31" name=""/>
+            <a:srgbClr val="F0521E"/>
+          </a:solidFill>
+          <a:ln/>
+        </p:spPr>
+      </p:sp>
+      <p:sp>
+        <p:nvSpPr>
+          <p:cNvPr id="32" name=""/>
           <p:cNvSpPr txBox="1"/>
           <p:nvPr/>
         </p:nvSpPr>
@@ -13746,7 +13770,7 @@
             <a:r>
               <a:rPr sz="1350" b="1">
                 <a:solidFill>
-                  <a:srgbClr val="1A2238"/>
+                  <a:srgbClr val="FFFFFF"/>
                 </a:solidFill>
                 <a:latin typeface="DM Sans"/>
                 <a:ea typeface="DM Sans"/>
@@ -13758,7 +13782,7 @@
       </p:sp>
       <p:sp>
         <p:nvSpPr>
-          <p:cNvPr id="32" name=""/>
+          <p:cNvPr id="33" name=""/>
           <p:cNvSpPr txBox="1"/>
           <p:nvPr/>
         </p:nvSpPr>
@@ -13793,7 +13817,7 @@
       </p:sp>
       <p:sp>
         <p:nvSpPr>
-          <p:cNvPr id="33" name=""/>
+          <p:cNvPr id="34" name=""/>
           <p:cNvSpPr/>
           <p:nvPr/>
         </p:nvSpPr>
@@ -13815,7 +13839,7 @@
       </p:sp>
       <p:sp>
         <p:nvSpPr>
-          <p:cNvPr id="34" name=""/>
+          <p:cNvPr id="35" name=""/>
           <p:cNvSpPr/>
           <p:nvPr/>
         </p:nvSpPr>
@@ -13828,14 +13852,14 @@
             <a:avLst/>
           </a:prstGeom>
           <a:solidFill>
-            <a:srgbClr val="FFD966"/>
-          </a:solidFill>
-          <a:ln/>
-        </p:spPr>
-      </p:sp>
-      <p:sp>
-        <p:nvSpPr>
-          <p:cNvPr id="35" name=""/>
+            <a:srgbClr val="F0521E"/>
+          </a:solidFill>
+          <a:ln/>
+        </p:spPr>
+      </p:sp>
+      <p:sp>
+        <p:nvSpPr>
+          <p:cNvPr id="36" name=""/>
           <p:cNvSpPr txBox="1"/>
           <p:nvPr/>
         </p:nvSpPr>
@@ -13858,7 +13882,7 @@
             <a:r>
               <a:rPr sz="1350" b="1">
                 <a:solidFill>
-                  <a:srgbClr val="1A2238"/>
+                  <a:srgbClr val="FFFFFF"/>
                 </a:solidFill>
                 <a:latin typeface="DM Sans"/>
                 <a:ea typeface="DM Sans"/>
@@ -13870,7 +13894,7 @@
       </p:sp>
       <p:sp>
         <p:nvSpPr>
-          <p:cNvPr id="36" name=""/>
+          <p:cNvPr id="37" name=""/>
           <p:cNvSpPr txBox="1"/>
           <p:nvPr/>
         </p:nvSpPr>
@@ -13905,7 +13929,7 @@
       </p:sp>
       <p:sp>
         <p:nvSpPr>
-          <p:cNvPr id="37" name=""/>
+          <p:cNvPr id="38" name=""/>
           <p:cNvSpPr/>
           <p:nvPr/>
         </p:nvSpPr>
@@ -13946,7 +13970,7 @@
       </p:sp>
       <p:sp>
         <p:nvSpPr>
-          <p:cNvPr id="38" name=""/>
+          <p:cNvPr id="39" name=""/>
           <p:cNvSpPr/>
           <p:nvPr/>
         </p:nvSpPr>
@@ -13987,7 +14011,7 @@
       </p:sp>
       <p:sp>
         <p:nvSpPr>
-          <p:cNvPr id="39" name=""/>
+          <p:cNvPr id="40" name=""/>
           <p:cNvSpPr/>
           <p:nvPr/>
         </p:nvSpPr>
@@ -14028,7 +14052,7 @@
       </p:sp>
       <p:sp>
         <p:nvSpPr>
-          <p:cNvPr id="40" name=""/>
+          <p:cNvPr id="41" name=""/>
           <p:cNvSpPr/>
           <p:nvPr/>
         </p:nvSpPr>
@@ -14063,280 +14087,6 @@
           </a:custGeom>
           <a:solidFill>
             <a:srgbClr val="F0521E"/>
-          </a:solidFill>
-          <a:ln/>
-        </p:spPr>
-      </p:sp>
-      <p:sp>
-        <p:nvSpPr>
-          <p:cNvPr id="41" name=""/>
-          <p:cNvSpPr/>
-          <p:nvPr/>
-        </p:nvSpPr>
-        <p:spPr>
-          <a:xfrm>
-            <a:off x="10715625" y="1371600"/>
-            <a:ext cx="466725" cy="447675"/>
-          </a:xfrm>
-          <a:custGeom>
-            <a:avLst/>
-            <a:gdLst/>
-            <a:ahLst/>
-            <a:cxnLst/>
-            <a:rect l="l" t="t" r="r" b="b"/>
-            <a:pathLst>
-              <a:path w="466725" h="447675">
-                <a:moveTo>
-                  <a:pt x="235268" y="0"/>
-                </a:moveTo>
-                <a:lnTo>
-                  <a:pt x="300990" y="157163"/>
-                </a:lnTo>
-                <a:lnTo>
-                  <a:pt x="470535" y="171450"/>
-                </a:lnTo>
-                <a:lnTo>
-                  <a:pt x="340995" y="281940"/>
-                </a:lnTo>
-                <a:lnTo>
-                  <a:pt x="381000" y="447675"/>
-                </a:lnTo>
-                <a:lnTo>
-                  <a:pt x="235268" y="359092"/>
-                </a:lnTo>
-                <a:lnTo>
-                  <a:pt x="89535" y="447675"/>
-                </a:lnTo>
-                <a:lnTo>
-                  <a:pt x="129540" y="281940"/>
-                </a:lnTo>
-                <a:lnTo>
-                  <a:pt x="0" y="171450"/>
-                </a:lnTo>
-                <a:lnTo>
-                  <a:pt x="169545" y="157163"/>
-                </a:lnTo>
-                <a:close/>
-              </a:path>
-            </a:pathLst>
-          </a:custGeom>
-          <a:solidFill>
-            <a:srgbClr val="FFD966"/>
-          </a:solidFill>
-          <a:ln/>
-        </p:spPr>
-      </p:sp>
-      <p:sp>
-        <p:nvSpPr>
-          <p:cNvPr id="42" name=""/>
-          <p:cNvSpPr/>
-          <p:nvPr/>
-        </p:nvSpPr>
-        <p:spPr>
-          <a:xfrm>
-            <a:off x="8058150" y="2371725"/>
-            <a:ext cx="238125" cy="228600"/>
-          </a:xfrm>
-          <a:custGeom>
-            <a:avLst/>
-            <a:gdLst/>
-            <a:ahLst/>
-            <a:cxnLst/>
-            <a:rect l="l" t="t" r="r" b="b"/>
-            <a:pathLst>
-              <a:path w="238125" h="228600">
-                <a:moveTo>
-                  <a:pt x="118110" y="0"/>
-                </a:moveTo>
-                <a:lnTo>
-                  <a:pt x="150495" y="79058"/>
-                </a:lnTo>
-                <a:lnTo>
-                  <a:pt x="236220" y="85725"/>
-                </a:lnTo>
-                <a:lnTo>
-                  <a:pt x="171450" y="140970"/>
-                </a:lnTo>
-                <a:lnTo>
-                  <a:pt x="190500" y="223838"/>
-                </a:lnTo>
-                <a:lnTo>
-                  <a:pt x="118110" y="180022"/>
-                </a:lnTo>
-                <a:lnTo>
-                  <a:pt x="45720" y="223838"/>
-                </a:lnTo>
-                <a:lnTo>
-                  <a:pt x="64770" y="140970"/>
-                </a:lnTo>
-                <a:lnTo>
-                  <a:pt x="0" y="85725"/>
-                </a:lnTo>
-                <a:lnTo>
-                  <a:pt x="85725" y="79058"/>
-                </a:lnTo>
-                <a:close/>
-              </a:path>
-            </a:pathLst>
-          </a:custGeom>
-          <a:solidFill>
-            <a:srgbClr val="FFD966"/>
-          </a:solidFill>
-          <a:ln/>
-        </p:spPr>
-      </p:sp>
-      <p:sp>
-        <p:nvSpPr>
-          <p:cNvPr id="43" name=""/>
-          <p:cNvSpPr/>
-          <p:nvPr/>
-        </p:nvSpPr>
-        <p:spPr>
-          <a:xfrm>
-            <a:off x="8258175" y="1247775"/>
-            <a:ext cx="323850" cy="323850"/>
-          </a:xfrm>
-          <a:custGeom>
-            <a:avLst/>
-            <a:gdLst/>
-            <a:ahLst/>
-            <a:cxnLst/>
-            <a:rect l="l" t="t" r="r" b="b"/>
-            <a:pathLst>
-              <a:path w="323850" h="323850">
-                <a:moveTo>
-                  <a:pt x="161925" y="0"/>
-                </a:moveTo>
-                <a:cubicBezTo>
-                  <a:pt x="184785" y="139065"/>
-                  <a:pt x="184785" y="139065"/>
-                  <a:pt x="323850" y="161925"/>
-                </a:cubicBezTo>
-                <a:cubicBezTo>
-                  <a:pt x="184785" y="184785"/>
-                  <a:pt x="184785" y="184785"/>
-                  <a:pt x="161925" y="323850"/>
-                </a:cubicBezTo>
-                <a:cubicBezTo>
-                  <a:pt x="139065" y="184785"/>
-                  <a:pt x="139065" y="184785"/>
-                  <a:pt x="0" y="161925"/>
-                </a:cubicBezTo>
-                <a:cubicBezTo>
-                  <a:pt x="139065" y="139065"/>
-                  <a:pt x="139065" y="139065"/>
-                  <a:pt x="161925" y="0"/>
-                </a:cubicBezTo>
-                <a:close/>
-              </a:path>
-            </a:pathLst>
-          </a:custGeom>
-          <a:solidFill>
-            <a:srgbClr val="FFFFFF"/>
-          </a:solidFill>
-          <a:ln/>
-        </p:spPr>
-      </p:sp>
-      <p:sp>
-        <p:nvSpPr>
-          <p:cNvPr id="44" name=""/>
-          <p:cNvSpPr/>
-          <p:nvPr/>
-        </p:nvSpPr>
-        <p:spPr>
-          <a:xfrm>
-            <a:off x="11696700" y="2552700"/>
-            <a:ext cx="228600" cy="228600"/>
-          </a:xfrm>
-          <a:custGeom>
-            <a:avLst/>
-            <a:gdLst/>
-            <a:ahLst/>
-            <a:cxnLst/>
-            <a:rect l="l" t="t" r="r" b="b"/>
-            <a:pathLst>
-              <a:path w="228600" h="228600">
-                <a:moveTo>
-                  <a:pt x="114300" y="0"/>
-                </a:moveTo>
-                <a:cubicBezTo>
-                  <a:pt x="130493" y="98108"/>
-                  <a:pt x="130493" y="98108"/>
-                  <a:pt x="228600" y="114300"/>
-                </a:cubicBezTo>
-                <a:cubicBezTo>
-                  <a:pt x="130493" y="130492"/>
-                  <a:pt x="130493" y="130492"/>
-                  <a:pt x="114300" y="228600"/>
-                </a:cubicBezTo>
-                <a:cubicBezTo>
-                  <a:pt x="98107" y="130492"/>
-                  <a:pt x="98107" y="130492"/>
-                  <a:pt x="0" y="114300"/>
-                </a:cubicBezTo>
-                <a:cubicBezTo>
-                  <a:pt x="98107" y="98108"/>
-                  <a:pt x="98107" y="98108"/>
-                  <a:pt x="114300" y="0"/>
-                </a:cubicBezTo>
-                <a:close/>
-              </a:path>
-            </a:pathLst>
-          </a:custGeom>
-          <a:solidFill>
-            <a:srgbClr val="FFFFFF"/>
-          </a:solidFill>
-          <a:ln/>
-        </p:spPr>
-      </p:sp>
-      <p:sp>
-        <p:nvSpPr>
-          <p:cNvPr id="45" name=""/>
-          <p:cNvSpPr/>
-          <p:nvPr/>
-        </p:nvSpPr>
-        <p:spPr>
-          <a:xfrm>
-            <a:off x="7219950" y="5219700"/>
-            <a:ext cx="228600" cy="228600"/>
-          </a:xfrm>
-          <a:custGeom>
-            <a:avLst/>
-            <a:gdLst/>
-            <a:ahLst/>
-            <a:cxnLst/>
-            <a:rect l="l" t="t" r="r" b="b"/>
-            <a:pathLst>
-              <a:path w="228600" h="228600">
-                <a:moveTo>
-                  <a:pt x="114300" y="0"/>
-                </a:moveTo>
-                <a:cubicBezTo>
-                  <a:pt x="130493" y="98107"/>
-                  <a:pt x="130493" y="98107"/>
-                  <a:pt x="228600" y="114300"/>
-                </a:cubicBezTo>
-                <a:cubicBezTo>
-                  <a:pt x="130493" y="130493"/>
-                  <a:pt x="130493" y="130493"/>
-                  <a:pt x="114300" y="228600"/>
-                </a:cubicBezTo>
-                <a:cubicBezTo>
-                  <a:pt x="98107" y="130493"/>
-                  <a:pt x="98107" y="130493"/>
-                  <a:pt x="0" y="114300"/>
-                </a:cubicBezTo>
-                <a:cubicBezTo>
-                  <a:pt x="98107" y="98107"/>
-                  <a:pt x="98107" y="98107"/>
-                  <a:pt x="114300" y="0"/>
-                </a:cubicBezTo>
-                <a:close/>
-              </a:path>
-            </a:pathLst>
-          </a:custGeom>
-          <a:solidFill>
-            <a:srgbClr val="FFD966"/>
           </a:solidFill>
           <a:ln/>
         </p:spPr>
@@ -14582,7 +14332,7 @@
             </a:pathLst>
           </a:custGeom>
           <a:solidFill>
-            <a:srgbClr val="F36B3D"/>
+            <a:srgbClr val="F25F2D"/>
           </a:solidFill>
           <a:ln/>
         </p:spPr>
@@ -14773,7 +14523,7 @@
             </a:avLst>
           </a:prstGeom>
           <a:solidFill>
-            <a:srgbClr val="FFD966"/>
+            <a:srgbClr val="FFFFFF"/>
           </a:solidFill>
           <a:ln/>
         </p:spPr>
@@ -14803,7 +14553,7 @@
             <a:r>
               <a:rPr sz="1500" b="1">
                 <a:solidFill>
-                  <a:srgbClr val="1A2238"/>
+                  <a:srgbClr val="C23B12"/>
                 </a:solidFill>
                 <a:latin typeface="Noto Sans JP"/>
                 <a:ea typeface="Noto Sans JP"/>
@@ -14821,53 +14571,77 @@
         </p:nvSpPr>
         <p:spPr>
           <a:xfrm>
-            <a:off x="609600" y="1343025"/>
-            <a:ext cx="7286625" cy="942975"/>
-          </a:xfrm>
-          <a:prstGeom prst="rect">
-            <a:avLst/>
-          </a:prstGeom>
-          <a:noFill/>
-          <a:ln/>
-        </p:spPr>
-        <p:txBody>
-          <a:bodyPr wrap="square" lIns="0" tIns="0" rIns="0" bIns="0" anchor="ctr"/>
-          <a:lstStyle/>
-          <a:p>
-            <a:pPr/>
-            <a:r>
-              <a:rPr sz="5700" b="1" spc="-75" kern="0">
+            <a:off x="676275" y="1352550"/>
+            <a:ext cx="8401050" cy="1266825"/>
+          </a:xfrm>
+          <a:prstGeom prst="rect">
+            <a:avLst/>
+          </a:prstGeom>
+          <a:noFill/>
+          <a:ln/>
+        </p:spPr>
+        <p:txBody>
+          <a:bodyPr wrap="square" lIns="0" tIns="0" rIns="0" bIns="0" anchor="ctr"/>
+          <a:lstStyle/>
+          <a:p>
+            <a:pPr/>
+            <a:r>
+              <a:rPr sz="6900">
+                <a:solidFill>
+                  <a:srgbClr val="A3300B"/>
+                </a:solidFill>
+                <a:latin typeface="Reggae One"/>
+                <a:ea typeface="Reggae One"/>
+              </a:rPr>
+              <a:t>チャレンジタイム</a:t>
+            </a:r>
+          </a:p>
+        </p:txBody>
+      </p:sp>
+      <p:sp>
+        <p:nvSpPr>
+          <p:cNvPr id="12" name=""/>
+          <p:cNvSpPr txBox="1"/>
+          <p:nvPr/>
+        </p:nvSpPr>
+        <p:spPr>
+          <a:xfrm>
+            <a:off x="609600" y="1285875"/>
+            <a:ext cx="8401050" cy="1266825"/>
+          </a:xfrm>
+          <a:prstGeom prst="rect">
+            <a:avLst/>
+          </a:prstGeom>
+          <a:noFill/>
+          <a:ln/>
+        </p:spPr>
+        <p:txBody>
+          <a:bodyPr wrap="square" lIns="0" tIns="0" rIns="0" bIns="0" anchor="ctr"/>
+          <a:lstStyle/>
+          <a:p>
+            <a:pPr/>
+            <a:r>
+              <a:rPr sz="6900">
                 <a:solidFill>
                   <a:srgbClr val="FFFFFF"/>
                 </a:solidFill>
-                <a:latin typeface="DM Sans"/>
-                <a:ea typeface="DM Sans"/>
-              </a:rPr>
-              <a:t>CHALLENGE </a:t>
-            </a:r>
-            <a:pPr/>
-            <a:r>
-              <a:rPr sz="5700" b="1" spc="-75" kern="0">
-                <a:solidFill>
-                  <a:srgbClr val="FFD966"/>
-                </a:solidFill>
-                <a:latin typeface="DM Sans"/>
-                <a:ea typeface="DM Sans"/>
-              </a:rPr>
-              <a:t>TIME</a:t>
-            </a:r>
-          </a:p>
-        </p:txBody>
-      </p:sp>
-      <p:sp>
-        <p:nvSpPr>
-          <p:cNvPr id="12" name=""/>
-          <p:cNvSpPr/>
-          <p:nvPr/>
-        </p:nvSpPr>
-        <p:spPr>
-          <a:xfrm>
-            <a:off x="609600" y="2943225"/>
+                <a:latin typeface="Reggae One"/>
+                <a:ea typeface="Reggae One"/>
+              </a:rPr>
+              <a:t>チャレンジタイム</a:t>
+            </a:r>
+          </a:p>
+        </p:txBody>
+      </p:sp>
+      <p:sp>
+        <p:nvSpPr>
+          <p:cNvPr id="13" name=""/>
+          <p:cNvSpPr/>
+          <p:nvPr/>
+        </p:nvSpPr>
+        <p:spPr>
+          <a:xfrm>
+            <a:off x="609600" y="3105150"/>
             <a:ext cx="7658100" cy="2028825"/>
           </a:xfrm>
           <a:prstGeom prst="roundRect">
@@ -14890,13 +14664,13 @@
       </p:sp>
       <p:sp>
         <p:nvSpPr>
-          <p:cNvPr id="13" name=""/>
-          <p:cNvSpPr txBox="1"/>
-          <p:nvPr/>
-        </p:nvSpPr>
-        <p:spPr>
-          <a:xfrm>
-            <a:off x="933450" y="3152775"/>
+          <p:cNvPr id="14" name=""/>
+          <p:cNvSpPr txBox="1"/>
+          <p:nvPr/>
+        </p:nvSpPr>
+        <p:spPr>
+          <a:xfrm>
+            <a:off x="933450" y="3314700"/>
             <a:ext cx="1362075" cy="171450"/>
           </a:xfrm>
           <a:prstGeom prst="rect">
@@ -14925,13 +14699,13 @@
       </p:sp>
       <p:sp>
         <p:nvSpPr>
-          <p:cNvPr id="14" name=""/>
-          <p:cNvSpPr txBox="1"/>
-          <p:nvPr/>
-        </p:nvSpPr>
-        <p:spPr>
-          <a:xfrm>
-            <a:off x="933450" y="3381375"/>
+          <p:cNvPr id="15" name=""/>
+          <p:cNvSpPr txBox="1"/>
+          <p:nvPr/>
+        </p:nvSpPr>
+        <p:spPr>
+          <a:xfrm>
+            <a:off x="933450" y="3543300"/>
             <a:ext cx="7343775" cy="523875"/>
           </a:xfrm>
           <a:prstGeom prst="rect">
@@ -14982,13 +14756,13 @@
       </p:sp>
       <p:sp>
         <p:nvSpPr>
-          <p:cNvPr id="15" name=""/>
-          <p:cNvSpPr txBox="1"/>
-          <p:nvPr/>
-        </p:nvSpPr>
-        <p:spPr>
-          <a:xfrm>
-            <a:off x="933450" y="3924300"/>
+          <p:cNvPr id="16" name=""/>
+          <p:cNvSpPr txBox="1"/>
+          <p:nvPr/>
+        </p:nvSpPr>
+        <p:spPr>
+          <a:xfrm>
+            <a:off x="933450" y="4086225"/>
             <a:ext cx="2314575" cy="276225"/>
           </a:xfrm>
           <a:prstGeom prst="rect">
@@ -15017,13 +14791,13 @@
       </p:sp>
       <p:sp>
         <p:nvSpPr>
-          <p:cNvPr id="16" name=""/>
-          <p:cNvSpPr/>
-          <p:nvPr/>
-        </p:nvSpPr>
-        <p:spPr>
-          <a:xfrm>
-            <a:off x="933450" y="4352925"/>
+          <p:cNvPr id="17" name=""/>
+          <p:cNvSpPr/>
+          <p:nvPr/>
+        </p:nvSpPr>
+        <p:spPr>
+          <a:xfrm>
+            <a:off x="933450" y="4514850"/>
             <a:ext cx="1066800" cy="371475"/>
           </a:xfrm>
           <a:prstGeom prst="roundRect">
@@ -15039,13 +14813,13 @@
       </p:sp>
       <p:sp>
         <p:nvSpPr>
-          <p:cNvPr id="17" name=""/>
-          <p:cNvSpPr txBox="1"/>
-          <p:nvPr/>
-        </p:nvSpPr>
-        <p:spPr>
-          <a:xfrm>
-            <a:off x="1085850" y="4410075"/>
+          <p:cNvPr id="18" name=""/>
+          <p:cNvSpPr txBox="1"/>
+          <p:nvPr/>
+        </p:nvSpPr>
+        <p:spPr>
+          <a:xfrm>
+            <a:off x="1085850" y="4572000"/>
             <a:ext cx="1219200" cy="247650"/>
           </a:xfrm>
           <a:prstGeom prst="rect">
@@ -15074,13 +14848,13 @@
       </p:sp>
       <p:sp>
         <p:nvSpPr>
-          <p:cNvPr id="18" name=""/>
-          <p:cNvSpPr/>
-          <p:nvPr/>
-        </p:nvSpPr>
-        <p:spPr>
-          <a:xfrm>
-            <a:off x="2095500" y="4352925"/>
+          <p:cNvPr id="19" name=""/>
+          <p:cNvSpPr/>
+          <p:nvPr/>
+        </p:nvSpPr>
+        <p:spPr>
+          <a:xfrm>
+            <a:off x="2095500" y="4514850"/>
             <a:ext cx="1066800" cy="371475"/>
           </a:xfrm>
           <a:prstGeom prst="roundRect">
@@ -15096,13 +14870,13 @@
       </p:sp>
       <p:sp>
         <p:nvSpPr>
-          <p:cNvPr id="19" name=""/>
-          <p:cNvSpPr txBox="1"/>
-          <p:nvPr/>
-        </p:nvSpPr>
-        <p:spPr>
-          <a:xfrm>
-            <a:off x="2247900" y="4410075"/>
+          <p:cNvPr id="20" name=""/>
+          <p:cNvSpPr txBox="1"/>
+          <p:nvPr/>
+        </p:nvSpPr>
+        <p:spPr>
+          <a:xfrm>
+            <a:off x="2247900" y="4572000"/>
             <a:ext cx="1219200" cy="247650"/>
           </a:xfrm>
           <a:prstGeom prst="rect">
@@ -15131,13 +14905,13 @@
       </p:sp>
       <p:sp>
         <p:nvSpPr>
-          <p:cNvPr id="20" name=""/>
-          <p:cNvSpPr/>
-          <p:nvPr/>
-        </p:nvSpPr>
-        <p:spPr>
-          <a:xfrm>
-            <a:off x="3257550" y="4352925"/>
+          <p:cNvPr id="21" name=""/>
+          <p:cNvSpPr/>
+          <p:nvPr/>
+        </p:nvSpPr>
+        <p:spPr>
+          <a:xfrm>
+            <a:off x="3257550" y="4514850"/>
             <a:ext cx="1104900" cy="371475"/>
           </a:xfrm>
           <a:prstGeom prst="roundRect">
@@ -15153,13 +14927,13 @@
       </p:sp>
       <p:sp>
         <p:nvSpPr>
-          <p:cNvPr id="21" name=""/>
-          <p:cNvSpPr txBox="1"/>
-          <p:nvPr/>
-        </p:nvSpPr>
-        <p:spPr>
-          <a:xfrm>
-            <a:off x="3409950" y="4410075"/>
+          <p:cNvPr id="22" name=""/>
+          <p:cNvSpPr txBox="1"/>
+          <p:nvPr/>
+        </p:nvSpPr>
+        <p:spPr>
+          <a:xfrm>
+            <a:off x="3409950" y="4572000"/>
             <a:ext cx="1266825" cy="247650"/>
           </a:xfrm>
           <a:prstGeom prst="rect">
@@ -15188,13 +14962,13 @@
       </p:sp>
       <p:sp>
         <p:nvSpPr>
-          <p:cNvPr id="22" name=""/>
-          <p:cNvSpPr/>
-          <p:nvPr/>
-        </p:nvSpPr>
-        <p:spPr>
-          <a:xfrm>
-            <a:off x="8867775" y="2667000"/>
+          <p:cNvPr id="23" name=""/>
+          <p:cNvSpPr/>
+          <p:nvPr/>
+        </p:nvSpPr>
+        <p:spPr>
+          <a:xfrm>
+            <a:off x="8867775" y="2838450"/>
             <a:ext cx="2571750" cy="2571750"/>
           </a:xfrm>
           <a:prstGeom prst="ellipse">
@@ -15205,7 +14979,7 @@
           </a:solidFill>
           <a:ln w="171450">
             <a:solidFill>
-              <a:srgbClr val="FFD966"/>
+              <a:srgbClr val="FFD3C2"/>
             </a:solidFill>
             <a:prstDash val="solid"/>
           </a:ln>
@@ -15220,13 +14994,13 @@
       </p:sp>
       <p:sp>
         <p:nvSpPr>
-          <p:cNvPr id="23" name=""/>
-          <p:cNvSpPr txBox="1"/>
-          <p:nvPr/>
-        </p:nvSpPr>
-        <p:spPr>
-          <a:xfrm>
-            <a:off x="9382125" y="3286125"/>
+          <p:cNvPr id="24" name=""/>
+          <p:cNvSpPr txBox="1"/>
+          <p:nvPr/>
+        </p:nvSpPr>
+        <p:spPr>
+          <a:xfrm>
+            <a:off x="9382125" y="3457575"/>
             <a:ext cx="2124075" cy="1038225"/>
           </a:xfrm>
           <a:prstGeom prst="rect">
@@ -15255,13 +15029,13 @@
       </p:sp>
       <p:sp>
         <p:nvSpPr>
-          <p:cNvPr id="24" name=""/>
-          <p:cNvSpPr txBox="1"/>
-          <p:nvPr/>
-        </p:nvSpPr>
-        <p:spPr>
-          <a:xfrm>
-            <a:off x="9725025" y="4305300"/>
+          <p:cNvPr id="25" name=""/>
+          <p:cNvSpPr txBox="1"/>
+          <p:nvPr/>
+        </p:nvSpPr>
+        <p:spPr>
+          <a:xfrm>
+            <a:off x="9725025" y="4476750"/>
             <a:ext cx="1323975" cy="190500"/>
           </a:xfrm>
           <a:prstGeom prst="rect">
@@ -15290,7 +15064,7 @@
       </p:sp>
       <p:sp>
         <p:nvSpPr>
-          <p:cNvPr id="25" name=""/>
+          <p:cNvPr id="26" name=""/>
           <p:cNvSpPr/>
           <p:nvPr/>
         </p:nvSpPr>
@@ -15312,7 +15086,7 @@
       </p:sp>
       <p:sp>
         <p:nvSpPr>
-          <p:cNvPr id="26" name=""/>
+          <p:cNvPr id="27" name=""/>
           <p:cNvSpPr/>
           <p:nvPr/>
         </p:nvSpPr>
@@ -15325,14 +15099,14 @@
             <a:avLst/>
           </a:prstGeom>
           <a:solidFill>
-            <a:srgbClr val="FFD966"/>
-          </a:solidFill>
-          <a:ln/>
-        </p:spPr>
-      </p:sp>
-      <p:sp>
-        <p:nvSpPr>
-          <p:cNvPr id="27" name=""/>
+            <a:srgbClr val="F0521E"/>
+          </a:solidFill>
+          <a:ln/>
+        </p:spPr>
+      </p:sp>
+      <p:sp>
+        <p:nvSpPr>
+          <p:cNvPr id="28" name=""/>
           <p:cNvSpPr txBox="1"/>
           <p:nvPr/>
         </p:nvSpPr>
@@ -15355,7 +15129,7 @@
             <a:r>
               <a:rPr sz="1350" b="1">
                 <a:solidFill>
-                  <a:srgbClr val="1A2238"/>
+                  <a:srgbClr val="FFFFFF"/>
                 </a:solidFill>
                 <a:latin typeface="DM Sans"/>
                 <a:ea typeface="DM Sans"/>
@@ -15367,7 +15141,7 @@
       </p:sp>
       <p:sp>
         <p:nvSpPr>
-          <p:cNvPr id="28" name=""/>
+          <p:cNvPr id="29" name=""/>
           <p:cNvSpPr txBox="1"/>
           <p:nvPr/>
         </p:nvSpPr>
@@ -15402,7 +15176,7 @@
       </p:sp>
       <p:sp>
         <p:nvSpPr>
-          <p:cNvPr id="29" name=""/>
+          <p:cNvPr id="30" name=""/>
           <p:cNvSpPr/>
           <p:nvPr/>
         </p:nvSpPr>
@@ -15424,7 +15198,7 @@
       </p:sp>
       <p:sp>
         <p:nvSpPr>
-          <p:cNvPr id="30" name=""/>
+          <p:cNvPr id="31" name=""/>
           <p:cNvSpPr/>
           <p:nvPr/>
         </p:nvSpPr>
@@ -15437,14 +15211,14 @@
             <a:avLst/>
           </a:prstGeom>
           <a:solidFill>
-            <a:srgbClr val="FFD966"/>
-          </a:solidFill>
-          <a:ln/>
-        </p:spPr>
-      </p:sp>
-      <p:sp>
-        <p:nvSpPr>
-          <p:cNvPr id="31" name=""/>
+            <a:srgbClr val="F0521E"/>
+          </a:solidFill>
+          <a:ln/>
+        </p:spPr>
+      </p:sp>
+      <p:sp>
+        <p:nvSpPr>
+          <p:cNvPr id="32" name=""/>
           <p:cNvSpPr txBox="1"/>
           <p:nvPr/>
         </p:nvSpPr>
@@ -15467,7 +15241,7 @@
             <a:r>
               <a:rPr sz="1350" b="1">
                 <a:solidFill>
-                  <a:srgbClr val="1A2238"/>
+                  <a:srgbClr val="FFFFFF"/>
                 </a:solidFill>
                 <a:latin typeface="DM Sans"/>
                 <a:ea typeface="DM Sans"/>
@@ -15479,7 +15253,7 @@
       </p:sp>
       <p:sp>
         <p:nvSpPr>
-          <p:cNvPr id="32" name=""/>
+          <p:cNvPr id="33" name=""/>
           <p:cNvSpPr txBox="1"/>
           <p:nvPr/>
         </p:nvSpPr>
@@ -15514,7 +15288,7 @@
       </p:sp>
       <p:sp>
         <p:nvSpPr>
-          <p:cNvPr id="33" name=""/>
+          <p:cNvPr id="34" name=""/>
           <p:cNvSpPr/>
           <p:nvPr/>
         </p:nvSpPr>
@@ -15536,7 +15310,7 @@
       </p:sp>
       <p:sp>
         <p:nvSpPr>
-          <p:cNvPr id="34" name=""/>
+          <p:cNvPr id="35" name=""/>
           <p:cNvSpPr/>
           <p:nvPr/>
         </p:nvSpPr>
@@ -15549,14 +15323,14 @@
             <a:avLst/>
           </a:prstGeom>
           <a:solidFill>
-            <a:srgbClr val="FFD966"/>
-          </a:solidFill>
-          <a:ln/>
-        </p:spPr>
-      </p:sp>
-      <p:sp>
-        <p:nvSpPr>
-          <p:cNvPr id="35" name=""/>
+            <a:srgbClr val="F0521E"/>
+          </a:solidFill>
+          <a:ln/>
+        </p:spPr>
+      </p:sp>
+      <p:sp>
+        <p:nvSpPr>
+          <p:cNvPr id="36" name=""/>
           <p:cNvSpPr txBox="1"/>
           <p:nvPr/>
         </p:nvSpPr>
@@ -15579,7 +15353,7 @@
             <a:r>
               <a:rPr sz="1350" b="1">
                 <a:solidFill>
-                  <a:srgbClr val="1A2238"/>
+                  <a:srgbClr val="FFFFFF"/>
                 </a:solidFill>
                 <a:latin typeface="DM Sans"/>
                 <a:ea typeface="DM Sans"/>
@@ -15591,7 +15365,7 @@
       </p:sp>
       <p:sp>
         <p:nvSpPr>
-          <p:cNvPr id="36" name=""/>
+          <p:cNvPr id="37" name=""/>
           <p:cNvSpPr txBox="1"/>
           <p:nvPr/>
         </p:nvSpPr>
@@ -15626,7 +15400,7 @@
       </p:sp>
       <p:sp>
         <p:nvSpPr>
-          <p:cNvPr id="37" name=""/>
+          <p:cNvPr id="38" name=""/>
           <p:cNvSpPr/>
           <p:nvPr/>
         </p:nvSpPr>
@@ -15667,7 +15441,7 @@
       </p:sp>
       <p:sp>
         <p:nvSpPr>
-          <p:cNvPr id="38" name=""/>
+          <p:cNvPr id="39" name=""/>
           <p:cNvSpPr/>
           <p:nvPr/>
         </p:nvSpPr>
@@ -15708,7 +15482,7 @@
       </p:sp>
       <p:sp>
         <p:nvSpPr>
-          <p:cNvPr id="39" name=""/>
+          <p:cNvPr id="40" name=""/>
           <p:cNvSpPr/>
           <p:nvPr/>
         </p:nvSpPr>
@@ -15749,7 +15523,7 @@
       </p:sp>
       <p:sp>
         <p:nvSpPr>
-          <p:cNvPr id="40" name=""/>
+          <p:cNvPr id="41" name=""/>
           <p:cNvSpPr/>
           <p:nvPr/>
         </p:nvSpPr>
@@ -15784,280 +15558,6 @@
           </a:custGeom>
           <a:solidFill>
             <a:srgbClr val="F0521E"/>
-          </a:solidFill>
-          <a:ln/>
-        </p:spPr>
-      </p:sp>
-      <p:sp>
-        <p:nvSpPr>
-          <p:cNvPr id="41" name=""/>
-          <p:cNvSpPr/>
-          <p:nvPr/>
-        </p:nvSpPr>
-        <p:spPr>
-          <a:xfrm>
-            <a:off x="10715625" y="1371600"/>
-            <a:ext cx="466725" cy="447675"/>
-          </a:xfrm>
-          <a:custGeom>
-            <a:avLst/>
-            <a:gdLst/>
-            <a:ahLst/>
-            <a:cxnLst/>
-            <a:rect l="l" t="t" r="r" b="b"/>
-            <a:pathLst>
-              <a:path w="466725" h="447675">
-                <a:moveTo>
-                  <a:pt x="235268" y="0"/>
-                </a:moveTo>
-                <a:lnTo>
-                  <a:pt x="300990" y="157163"/>
-                </a:lnTo>
-                <a:lnTo>
-                  <a:pt x="470535" y="171450"/>
-                </a:lnTo>
-                <a:lnTo>
-                  <a:pt x="340995" y="281940"/>
-                </a:lnTo>
-                <a:lnTo>
-                  <a:pt x="381000" y="447675"/>
-                </a:lnTo>
-                <a:lnTo>
-                  <a:pt x="235268" y="359092"/>
-                </a:lnTo>
-                <a:lnTo>
-                  <a:pt x="89535" y="447675"/>
-                </a:lnTo>
-                <a:lnTo>
-                  <a:pt x="129540" y="281940"/>
-                </a:lnTo>
-                <a:lnTo>
-                  <a:pt x="0" y="171450"/>
-                </a:lnTo>
-                <a:lnTo>
-                  <a:pt x="169545" y="157163"/>
-                </a:lnTo>
-                <a:close/>
-              </a:path>
-            </a:pathLst>
-          </a:custGeom>
-          <a:solidFill>
-            <a:srgbClr val="FFD966"/>
-          </a:solidFill>
-          <a:ln/>
-        </p:spPr>
-      </p:sp>
-      <p:sp>
-        <p:nvSpPr>
-          <p:cNvPr id="42" name=""/>
-          <p:cNvSpPr/>
-          <p:nvPr/>
-        </p:nvSpPr>
-        <p:spPr>
-          <a:xfrm>
-            <a:off x="8058150" y="2371725"/>
-            <a:ext cx="238125" cy="228600"/>
-          </a:xfrm>
-          <a:custGeom>
-            <a:avLst/>
-            <a:gdLst/>
-            <a:ahLst/>
-            <a:cxnLst/>
-            <a:rect l="l" t="t" r="r" b="b"/>
-            <a:pathLst>
-              <a:path w="238125" h="228600">
-                <a:moveTo>
-                  <a:pt x="118110" y="0"/>
-                </a:moveTo>
-                <a:lnTo>
-                  <a:pt x="150495" y="79058"/>
-                </a:lnTo>
-                <a:lnTo>
-                  <a:pt x="236220" y="85725"/>
-                </a:lnTo>
-                <a:lnTo>
-                  <a:pt x="171450" y="140970"/>
-                </a:lnTo>
-                <a:lnTo>
-                  <a:pt x="190500" y="223838"/>
-                </a:lnTo>
-                <a:lnTo>
-                  <a:pt x="118110" y="180022"/>
-                </a:lnTo>
-                <a:lnTo>
-                  <a:pt x="45720" y="223838"/>
-                </a:lnTo>
-                <a:lnTo>
-                  <a:pt x="64770" y="140970"/>
-                </a:lnTo>
-                <a:lnTo>
-                  <a:pt x="0" y="85725"/>
-                </a:lnTo>
-                <a:lnTo>
-                  <a:pt x="85725" y="79058"/>
-                </a:lnTo>
-                <a:close/>
-              </a:path>
-            </a:pathLst>
-          </a:custGeom>
-          <a:solidFill>
-            <a:srgbClr val="FFD966"/>
-          </a:solidFill>
-          <a:ln/>
-        </p:spPr>
-      </p:sp>
-      <p:sp>
-        <p:nvSpPr>
-          <p:cNvPr id="43" name=""/>
-          <p:cNvSpPr/>
-          <p:nvPr/>
-        </p:nvSpPr>
-        <p:spPr>
-          <a:xfrm>
-            <a:off x="8258175" y="1247775"/>
-            <a:ext cx="323850" cy="323850"/>
-          </a:xfrm>
-          <a:custGeom>
-            <a:avLst/>
-            <a:gdLst/>
-            <a:ahLst/>
-            <a:cxnLst/>
-            <a:rect l="l" t="t" r="r" b="b"/>
-            <a:pathLst>
-              <a:path w="323850" h="323850">
-                <a:moveTo>
-                  <a:pt x="161925" y="0"/>
-                </a:moveTo>
-                <a:cubicBezTo>
-                  <a:pt x="184785" y="139065"/>
-                  <a:pt x="184785" y="139065"/>
-                  <a:pt x="323850" y="161925"/>
-                </a:cubicBezTo>
-                <a:cubicBezTo>
-                  <a:pt x="184785" y="184785"/>
-                  <a:pt x="184785" y="184785"/>
-                  <a:pt x="161925" y="323850"/>
-                </a:cubicBezTo>
-                <a:cubicBezTo>
-                  <a:pt x="139065" y="184785"/>
-                  <a:pt x="139065" y="184785"/>
-                  <a:pt x="0" y="161925"/>
-                </a:cubicBezTo>
-                <a:cubicBezTo>
-                  <a:pt x="139065" y="139065"/>
-                  <a:pt x="139065" y="139065"/>
-                  <a:pt x="161925" y="0"/>
-                </a:cubicBezTo>
-                <a:close/>
-              </a:path>
-            </a:pathLst>
-          </a:custGeom>
-          <a:solidFill>
-            <a:srgbClr val="FFFFFF"/>
-          </a:solidFill>
-          <a:ln/>
-        </p:spPr>
-      </p:sp>
-      <p:sp>
-        <p:nvSpPr>
-          <p:cNvPr id="44" name=""/>
-          <p:cNvSpPr/>
-          <p:nvPr/>
-        </p:nvSpPr>
-        <p:spPr>
-          <a:xfrm>
-            <a:off x="11696700" y="2552700"/>
-            <a:ext cx="228600" cy="228600"/>
-          </a:xfrm>
-          <a:custGeom>
-            <a:avLst/>
-            <a:gdLst/>
-            <a:ahLst/>
-            <a:cxnLst/>
-            <a:rect l="l" t="t" r="r" b="b"/>
-            <a:pathLst>
-              <a:path w="228600" h="228600">
-                <a:moveTo>
-                  <a:pt x="114300" y="0"/>
-                </a:moveTo>
-                <a:cubicBezTo>
-                  <a:pt x="130493" y="98108"/>
-                  <a:pt x="130493" y="98108"/>
-                  <a:pt x="228600" y="114300"/>
-                </a:cubicBezTo>
-                <a:cubicBezTo>
-                  <a:pt x="130493" y="130492"/>
-                  <a:pt x="130493" y="130492"/>
-                  <a:pt x="114300" y="228600"/>
-                </a:cubicBezTo>
-                <a:cubicBezTo>
-                  <a:pt x="98107" y="130492"/>
-                  <a:pt x="98107" y="130492"/>
-                  <a:pt x="0" y="114300"/>
-                </a:cubicBezTo>
-                <a:cubicBezTo>
-                  <a:pt x="98107" y="98108"/>
-                  <a:pt x="98107" y="98108"/>
-                  <a:pt x="114300" y="0"/>
-                </a:cubicBezTo>
-                <a:close/>
-              </a:path>
-            </a:pathLst>
-          </a:custGeom>
-          <a:solidFill>
-            <a:srgbClr val="FFFFFF"/>
-          </a:solidFill>
-          <a:ln/>
-        </p:spPr>
-      </p:sp>
-      <p:sp>
-        <p:nvSpPr>
-          <p:cNvPr id="45" name=""/>
-          <p:cNvSpPr/>
-          <p:nvPr/>
-        </p:nvSpPr>
-        <p:spPr>
-          <a:xfrm>
-            <a:off x="7219950" y="5219700"/>
-            <a:ext cx="228600" cy="228600"/>
-          </a:xfrm>
-          <a:custGeom>
-            <a:avLst/>
-            <a:gdLst/>
-            <a:ahLst/>
-            <a:cxnLst/>
-            <a:rect l="l" t="t" r="r" b="b"/>
-            <a:pathLst>
-              <a:path w="228600" h="228600">
-                <a:moveTo>
-                  <a:pt x="114300" y="0"/>
-                </a:moveTo>
-                <a:cubicBezTo>
-                  <a:pt x="130493" y="98107"/>
-                  <a:pt x="130493" y="98107"/>
-                  <a:pt x="228600" y="114300"/>
-                </a:cubicBezTo>
-                <a:cubicBezTo>
-                  <a:pt x="130493" y="130493"/>
-                  <a:pt x="130493" y="130493"/>
-                  <a:pt x="114300" y="228600"/>
-                </a:cubicBezTo>
-                <a:cubicBezTo>
-                  <a:pt x="98107" y="130493"/>
-                  <a:pt x="98107" y="130493"/>
-                  <a:pt x="0" y="114300"/>
-                </a:cubicBezTo>
-                <a:cubicBezTo>
-                  <a:pt x="98107" y="98107"/>
-                  <a:pt x="98107" y="98107"/>
-                  <a:pt x="114300" y="0"/>
-                </a:cubicBezTo>
-                <a:close/>
-              </a:path>
-            </a:pathLst>
-          </a:custGeom>
-          <a:solidFill>
-            <a:srgbClr val="FFD966"/>
           </a:solidFill>
           <a:ln/>
         </p:spPr>
@@ -16303,7 +15803,7 @@
             </a:pathLst>
           </a:custGeom>
           <a:solidFill>
-            <a:srgbClr val="F36B3D"/>
+            <a:srgbClr val="F25F2D"/>
           </a:solidFill>
           <a:ln/>
         </p:spPr>
@@ -16494,7 +15994,7 @@
             </a:avLst>
           </a:prstGeom>
           <a:solidFill>
-            <a:srgbClr val="FFD966"/>
+            <a:srgbClr val="FFFFFF"/>
           </a:solidFill>
           <a:ln/>
         </p:spPr>
@@ -16524,7 +16024,7 @@
             <a:r>
               <a:rPr sz="1500" b="1">
                 <a:solidFill>
-                  <a:srgbClr val="1A2238"/>
+                  <a:srgbClr val="C23B12"/>
                 </a:solidFill>
                 <a:latin typeface="Noto Sans JP"/>
                 <a:ea typeface="Noto Sans JP"/>
@@ -16542,53 +16042,77 @@
         </p:nvSpPr>
         <p:spPr>
           <a:xfrm>
-            <a:off x="609600" y="1343025"/>
-            <a:ext cx="7286625" cy="942975"/>
-          </a:xfrm>
-          <a:prstGeom prst="rect">
-            <a:avLst/>
-          </a:prstGeom>
-          <a:noFill/>
-          <a:ln/>
-        </p:spPr>
-        <p:txBody>
-          <a:bodyPr wrap="square" lIns="0" tIns="0" rIns="0" bIns="0" anchor="ctr"/>
-          <a:lstStyle/>
-          <a:p>
-            <a:pPr/>
-            <a:r>
-              <a:rPr sz="5700" b="1" spc="-75" kern="0">
+            <a:off x="676275" y="1352550"/>
+            <a:ext cx="8401050" cy="1266825"/>
+          </a:xfrm>
+          <a:prstGeom prst="rect">
+            <a:avLst/>
+          </a:prstGeom>
+          <a:noFill/>
+          <a:ln/>
+        </p:spPr>
+        <p:txBody>
+          <a:bodyPr wrap="square" lIns="0" tIns="0" rIns="0" bIns="0" anchor="ctr"/>
+          <a:lstStyle/>
+          <a:p>
+            <a:pPr/>
+            <a:r>
+              <a:rPr sz="6900">
+                <a:solidFill>
+                  <a:srgbClr val="A3300B"/>
+                </a:solidFill>
+                <a:latin typeface="Reggae One"/>
+                <a:ea typeface="Reggae One"/>
+              </a:rPr>
+              <a:t>チャレンジタイム</a:t>
+            </a:r>
+          </a:p>
+        </p:txBody>
+      </p:sp>
+      <p:sp>
+        <p:nvSpPr>
+          <p:cNvPr id="12" name=""/>
+          <p:cNvSpPr txBox="1"/>
+          <p:nvPr/>
+        </p:nvSpPr>
+        <p:spPr>
+          <a:xfrm>
+            <a:off x="609600" y="1285875"/>
+            <a:ext cx="8401050" cy="1266825"/>
+          </a:xfrm>
+          <a:prstGeom prst="rect">
+            <a:avLst/>
+          </a:prstGeom>
+          <a:noFill/>
+          <a:ln/>
+        </p:spPr>
+        <p:txBody>
+          <a:bodyPr wrap="square" lIns="0" tIns="0" rIns="0" bIns="0" anchor="ctr"/>
+          <a:lstStyle/>
+          <a:p>
+            <a:pPr/>
+            <a:r>
+              <a:rPr sz="6900">
                 <a:solidFill>
                   <a:srgbClr val="FFFFFF"/>
                 </a:solidFill>
-                <a:latin typeface="DM Sans"/>
-                <a:ea typeface="DM Sans"/>
-              </a:rPr>
-              <a:t>CHALLENGE </a:t>
-            </a:r>
-            <a:pPr/>
-            <a:r>
-              <a:rPr sz="5700" b="1" spc="-75" kern="0">
-                <a:solidFill>
-                  <a:srgbClr val="FFD966"/>
-                </a:solidFill>
-                <a:latin typeface="DM Sans"/>
-                <a:ea typeface="DM Sans"/>
-              </a:rPr>
-              <a:t>TIME</a:t>
-            </a:r>
-          </a:p>
-        </p:txBody>
-      </p:sp>
-      <p:sp>
-        <p:nvSpPr>
-          <p:cNvPr id="12" name=""/>
-          <p:cNvSpPr/>
-          <p:nvPr/>
-        </p:nvSpPr>
-        <p:spPr>
-          <a:xfrm>
-            <a:off x="609600" y="2943225"/>
+                <a:latin typeface="Reggae One"/>
+                <a:ea typeface="Reggae One"/>
+              </a:rPr>
+              <a:t>チャレンジタイム</a:t>
+            </a:r>
+          </a:p>
+        </p:txBody>
+      </p:sp>
+      <p:sp>
+        <p:nvSpPr>
+          <p:cNvPr id="13" name=""/>
+          <p:cNvSpPr/>
+          <p:nvPr/>
+        </p:nvSpPr>
+        <p:spPr>
+          <a:xfrm>
+            <a:off x="609600" y="3105150"/>
             <a:ext cx="7658100" cy="2028825"/>
           </a:xfrm>
           <a:prstGeom prst="roundRect">
@@ -16611,13 +16135,13 @@
       </p:sp>
       <p:sp>
         <p:nvSpPr>
-          <p:cNvPr id="13" name=""/>
-          <p:cNvSpPr txBox="1"/>
-          <p:nvPr/>
-        </p:nvSpPr>
-        <p:spPr>
-          <a:xfrm>
-            <a:off x="933450" y="3152775"/>
+          <p:cNvPr id="14" name=""/>
+          <p:cNvSpPr txBox="1"/>
+          <p:nvPr/>
+        </p:nvSpPr>
+        <p:spPr>
+          <a:xfrm>
+            <a:off x="933450" y="3314700"/>
             <a:ext cx="1362075" cy="171450"/>
           </a:xfrm>
           <a:prstGeom prst="rect">
@@ -16646,13 +16170,13 @@
       </p:sp>
       <p:sp>
         <p:nvSpPr>
-          <p:cNvPr id="14" name=""/>
-          <p:cNvSpPr txBox="1"/>
-          <p:nvPr/>
-        </p:nvSpPr>
-        <p:spPr>
-          <a:xfrm>
-            <a:off x="933450" y="3381375"/>
+          <p:cNvPr id="15" name=""/>
+          <p:cNvSpPr txBox="1"/>
+          <p:nvPr/>
+        </p:nvSpPr>
+        <p:spPr>
+          <a:xfrm>
+            <a:off x="933450" y="3543300"/>
             <a:ext cx="7239000" cy="523875"/>
           </a:xfrm>
           <a:prstGeom prst="rect">
@@ -16703,13 +16227,13 @@
       </p:sp>
       <p:sp>
         <p:nvSpPr>
-          <p:cNvPr id="15" name=""/>
-          <p:cNvSpPr txBox="1"/>
-          <p:nvPr/>
-        </p:nvSpPr>
-        <p:spPr>
-          <a:xfrm>
-            <a:off x="933450" y="3924300"/>
+          <p:cNvPr id="16" name=""/>
+          <p:cNvSpPr txBox="1"/>
+          <p:nvPr/>
+        </p:nvSpPr>
+        <p:spPr>
+          <a:xfrm>
+            <a:off x="933450" y="4086225"/>
             <a:ext cx="2971800" cy="276225"/>
           </a:xfrm>
           <a:prstGeom prst="rect">
@@ -16738,13 +16262,13 @@
       </p:sp>
       <p:sp>
         <p:nvSpPr>
-          <p:cNvPr id="16" name=""/>
-          <p:cNvSpPr/>
-          <p:nvPr/>
-        </p:nvSpPr>
-        <p:spPr>
-          <a:xfrm>
-            <a:off x="933450" y="4352925"/>
+          <p:cNvPr id="17" name=""/>
+          <p:cNvSpPr/>
+          <p:nvPr/>
+        </p:nvSpPr>
+        <p:spPr>
+          <a:xfrm>
+            <a:off x="933450" y="4514850"/>
             <a:ext cx="1066800" cy="371475"/>
           </a:xfrm>
           <a:prstGeom prst="roundRect">
@@ -16760,13 +16284,13 @@
       </p:sp>
       <p:sp>
         <p:nvSpPr>
-          <p:cNvPr id="17" name=""/>
-          <p:cNvSpPr txBox="1"/>
-          <p:nvPr/>
-        </p:nvSpPr>
-        <p:spPr>
-          <a:xfrm>
-            <a:off x="1085850" y="4410075"/>
+          <p:cNvPr id="18" name=""/>
+          <p:cNvSpPr txBox="1"/>
+          <p:nvPr/>
+        </p:nvSpPr>
+        <p:spPr>
+          <a:xfrm>
+            <a:off x="1085850" y="4572000"/>
             <a:ext cx="1219200" cy="247650"/>
           </a:xfrm>
           <a:prstGeom prst="rect">
@@ -16795,13 +16319,13 @@
       </p:sp>
       <p:sp>
         <p:nvSpPr>
-          <p:cNvPr id="18" name=""/>
-          <p:cNvSpPr/>
-          <p:nvPr/>
-        </p:nvSpPr>
-        <p:spPr>
-          <a:xfrm>
-            <a:off x="2095500" y="4352925"/>
+          <p:cNvPr id="19" name=""/>
+          <p:cNvSpPr/>
+          <p:nvPr/>
+        </p:nvSpPr>
+        <p:spPr>
+          <a:xfrm>
+            <a:off x="2095500" y="4514850"/>
             <a:ext cx="1066800" cy="371475"/>
           </a:xfrm>
           <a:prstGeom prst="roundRect">
@@ -16817,13 +16341,13 @@
       </p:sp>
       <p:sp>
         <p:nvSpPr>
-          <p:cNvPr id="19" name=""/>
-          <p:cNvSpPr txBox="1"/>
-          <p:nvPr/>
-        </p:nvSpPr>
-        <p:spPr>
-          <a:xfrm>
-            <a:off x="2247900" y="4410075"/>
+          <p:cNvPr id="20" name=""/>
+          <p:cNvSpPr txBox="1"/>
+          <p:nvPr/>
+        </p:nvSpPr>
+        <p:spPr>
+          <a:xfrm>
+            <a:off x="2247900" y="4572000"/>
             <a:ext cx="1219200" cy="247650"/>
           </a:xfrm>
           <a:prstGeom prst="rect">
@@ -16852,13 +16376,13 @@
       </p:sp>
       <p:sp>
         <p:nvSpPr>
-          <p:cNvPr id="20" name=""/>
-          <p:cNvSpPr/>
-          <p:nvPr/>
-        </p:nvSpPr>
-        <p:spPr>
-          <a:xfrm>
-            <a:off x="3257550" y="4352925"/>
+          <p:cNvPr id="21" name=""/>
+          <p:cNvSpPr/>
+          <p:nvPr/>
+        </p:nvSpPr>
+        <p:spPr>
+          <a:xfrm>
+            <a:off x="3257550" y="4514850"/>
             <a:ext cx="1104900" cy="371475"/>
           </a:xfrm>
           <a:prstGeom prst="roundRect">
@@ -16874,13 +16398,13 @@
       </p:sp>
       <p:sp>
         <p:nvSpPr>
-          <p:cNvPr id="21" name=""/>
-          <p:cNvSpPr txBox="1"/>
-          <p:nvPr/>
-        </p:nvSpPr>
-        <p:spPr>
-          <a:xfrm>
-            <a:off x="3409950" y="4410075"/>
+          <p:cNvPr id="22" name=""/>
+          <p:cNvSpPr txBox="1"/>
+          <p:nvPr/>
+        </p:nvSpPr>
+        <p:spPr>
+          <a:xfrm>
+            <a:off x="3409950" y="4572000"/>
             <a:ext cx="1266825" cy="247650"/>
           </a:xfrm>
           <a:prstGeom prst="rect">
@@ -16909,13 +16433,13 @@
       </p:sp>
       <p:sp>
         <p:nvSpPr>
-          <p:cNvPr id="22" name=""/>
-          <p:cNvSpPr/>
-          <p:nvPr/>
-        </p:nvSpPr>
-        <p:spPr>
-          <a:xfrm>
-            <a:off x="8867775" y="2667000"/>
+          <p:cNvPr id="23" name=""/>
+          <p:cNvSpPr/>
+          <p:nvPr/>
+        </p:nvSpPr>
+        <p:spPr>
+          <a:xfrm>
+            <a:off x="8867775" y="2838450"/>
             <a:ext cx="2571750" cy="2571750"/>
           </a:xfrm>
           <a:prstGeom prst="ellipse">
@@ -16926,7 +16450,7 @@
           </a:solidFill>
           <a:ln w="171450">
             <a:solidFill>
-              <a:srgbClr val="FFD966"/>
+              <a:srgbClr val="FFD3C2"/>
             </a:solidFill>
             <a:prstDash val="solid"/>
           </a:ln>
@@ -16941,13 +16465,13 @@
       </p:sp>
       <p:sp>
         <p:nvSpPr>
-          <p:cNvPr id="23" name=""/>
-          <p:cNvSpPr txBox="1"/>
-          <p:nvPr/>
-        </p:nvSpPr>
-        <p:spPr>
-          <a:xfrm>
-            <a:off x="9382125" y="3286125"/>
+          <p:cNvPr id="24" name=""/>
+          <p:cNvSpPr txBox="1"/>
+          <p:nvPr/>
+        </p:nvSpPr>
+        <p:spPr>
+          <a:xfrm>
+            <a:off x="9382125" y="3457575"/>
             <a:ext cx="2124075" cy="1038225"/>
           </a:xfrm>
           <a:prstGeom prst="rect">
@@ -16976,13 +16500,13 @@
       </p:sp>
       <p:sp>
         <p:nvSpPr>
-          <p:cNvPr id="24" name=""/>
-          <p:cNvSpPr txBox="1"/>
-          <p:nvPr/>
-        </p:nvSpPr>
-        <p:spPr>
-          <a:xfrm>
-            <a:off x="9725025" y="4305300"/>
+          <p:cNvPr id="25" name=""/>
+          <p:cNvSpPr txBox="1"/>
+          <p:nvPr/>
+        </p:nvSpPr>
+        <p:spPr>
+          <a:xfrm>
+            <a:off x="9725025" y="4476750"/>
             <a:ext cx="1323975" cy="190500"/>
           </a:xfrm>
           <a:prstGeom prst="rect">
@@ -17011,7 +16535,7 @@
       </p:sp>
       <p:sp>
         <p:nvSpPr>
-          <p:cNvPr id="25" name=""/>
+          <p:cNvPr id="26" name=""/>
           <p:cNvSpPr/>
           <p:nvPr/>
         </p:nvSpPr>
@@ -17033,7 +16557,7 @@
       </p:sp>
       <p:sp>
         <p:nvSpPr>
-          <p:cNvPr id="26" name=""/>
+          <p:cNvPr id="27" name=""/>
           <p:cNvSpPr/>
           <p:nvPr/>
         </p:nvSpPr>
@@ -17046,14 +16570,14 @@
             <a:avLst/>
           </a:prstGeom>
           <a:solidFill>
-            <a:srgbClr val="FFD966"/>
-          </a:solidFill>
-          <a:ln/>
-        </p:spPr>
-      </p:sp>
-      <p:sp>
-        <p:nvSpPr>
-          <p:cNvPr id="27" name=""/>
+            <a:srgbClr val="F0521E"/>
+          </a:solidFill>
+          <a:ln/>
+        </p:spPr>
+      </p:sp>
+      <p:sp>
+        <p:nvSpPr>
+          <p:cNvPr id="28" name=""/>
           <p:cNvSpPr txBox="1"/>
           <p:nvPr/>
         </p:nvSpPr>
@@ -17076,7 +16600,7 @@
             <a:r>
               <a:rPr sz="1350" b="1">
                 <a:solidFill>
-                  <a:srgbClr val="1A2238"/>
+                  <a:srgbClr val="FFFFFF"/>
                 </a:solidFill>
                 <a:latin typeface="DM Sans"/>
                 <a:ea typeface="DM Sans"/>
@@ -17088,7 +16612,7 @@
       </p:sp>
       <p:sp>
         <p:nvSpPr>
-          <p:cNvPr id="28" name=""/>
+          <p:cNvPr id="29" name=""/>
           <p:cNvSpPr txBox="1"/>
           <p:nvPr/>
         </p:nvSpPr>
@@ -17123,7 +16647,7 @@
       </p:sp>
       <p:sp>
         <p:nvSpPr>
-          <p:cNvPr id="29" name=""/>
+          <p:cNvPr id="30" name=""/>
           <p:cNvSpPr/>
           <p:nvPr/>
         </p:nvSpPr>
@@ -17145,7 +16669,7 @@
       </p:sp>
       <p:sp>
         <p:nvSpPr>
-          <p:cNvPr id="30" name=""/>
+          <p:cNvPr id="31" name=""/>
           <p:cNvSpPr/>
           <p:nvPr/>
         </p:nvSpPr>
@@ -17158,14 +16682,14 @@
             <a:avLst/>
           </a:prstGeom>
           <a:solidFill>
-            <a:srgbClr val="FFD966"/>
-          </a:solidFill>
-          <a:ln/>
-        </p:spPr>
-      </p:sp>
-      <p:sp>
-        <p:nvSpPr>
-          <p:cNvPr id="31" name=""/>
+            <a:srgbClr val="F0521E"/>
+          </a:solidFill>
+          <a:ln/>
+        </p:spPr>
+      </p:sp>
+      <p:sp>
+        <p:nvSpPr>
+          <p:cNvPr id="32" name=""/>
           <p:cNvSpPr txBox="1"/>
           <p:nvPr/>
         </p:nvSpPr>
@@ -17188,7 +16712,7 @@
             <a:r>
               <a:rPr sz="1350" b="1">
                 <a:solidFill>
-                  <a:srgbClr val="1A2238"/>
+                  <a:srgbClr val="FFFFFF"/>
                 </a:solidFill>
                 <a:latin typeface="DM Sans"/>
                 <a:ea typeface="DM Sans"/>
@@ -17200,7 +16724,7 @@
       </p:sp>
       <p:sp>
         <p:nvSpPr>
-          <p:cNvPr id="32" name=""/>
+          <p:cNvPr id="33" name=""/>
           <p:cNvSpPr txBox="1"/>
           <p:nvPr/>
         </p:nvSpPr>
@@ -17235,7 +16759,7 @@
       </p:sp>
       <p:sp>
         <p:nvSpPr>
-          <p:cNvPr id="33" name=""/>
+          <p:cNvPr id="34" name=""/>
           <p:cNvSpPr/>
           <p:nvPr/>
         </p:nvSpPr>
@@ -17257,7 +16781,7 @@
       </p:sp>
       <p:sp>
         <p:nvSpPr>
-          <p:cNvPr id="34" name=""/>
+          <p:cNvPr id="35" name=""/>
           <p:cNvSpPr/>
           <p:nvPr/>
         </p:nvSpPr>
@@ -17270,14 +16794,14 @@
             <a:avLst/>
           </a:prstGeom>
           <a:solidFill>
-            <a:srgbClr val="FFD966"/>
-          </a:solidFill>
-          <a:ln/>
-        </p:spPr>
-      </p:sp>
-      <p:sp>
-        <p:nvSpPr>
-          <p:cNvPr id="35" name=""/>
+            <a:srgbClr val="F0521E"/>
+          </a:solidFill>
+          <a:ln/>
+        </p:spPr>
+      </p:sp>
+      <p:sp>
+        <p:nvSpPr>
+          <p:cNvPr id="36" name=""/>
           <p:cNvSpPr txBox="1"/>
           <p:nvPr/>
         </p:nvSpPr>
@@ -17300,7 +16824,7 @@
             <a:r>
               <a:rPr sz="1350" b="1">
                 <a:solidFill>
-                  <a:srgbClr val="1A2238"/>
+                  <a:srgbClr val="FFFFFF"/>
                 </a:solidFill>
                 <a:latin typeface="DM Sans"/>
                 <a:ea typeface="DM Sans"/>
@@ -17312,7 +16836,7 @@
       </p:sp>
       <p:sp>
         <p:nvSpPr>
-          <p:cNvPr id="36" name=""/>
+          <p:cNvPr id="37" name=""/>
           <p:cNvSpPr txBox="1"/>
           <p:nvPr/>
         </p:nvSpPr>
@@ -17347,7 +16871,7 @@
       </p:sp>
       <p:sp>
         <p:nvSpPr>
-          <p:cNvPr id="37" name=""/>
+          <p:cNvPr id="38" name=""/>
           <p:cNvSpPr/>
           <p:nvPr/>
         </p:nvSpPr>
@@ -17388,7 +16912,7 @@
       </p:sp>
       <p:sp>
         <p:nvSpPr>
-          <p:cNvPr id="38" name=""/>
+          <p:cNvPr id="39" name=""/>
           <p:cNvSpPr/>
           <p:nvPr/>
         </p:nvSpPr>
@@ -17429,7 +16953,7 @@
       </p:sp>
       <p:sp>
         <p:nvSpPr>
-          <p:cNvPr id="39" name=""/>
+          <p:cNvPr id="40" name=""/>
           <p:cNvSpPr/>
           <p:nvPr/>
         </p:nvSpPr>
@@ -17470,7 +16994,7 @@
       </p:sp>
       <p:sp>
         <p:nvSpPr>
-          <p:cNvPr id="40" name=""/>
+          <p:cNvPr id="41" name=""/>
           <p:cNvSpPr/>
           <p:nvPr/>
         </p:nvSpPr>
@@ -17505,280 +17029,6 @@
           </a:custGeom>
           <a:solidFill>
             <a:srgbClr val="F0521E"/>
-          </a:solidFill>
-          <a:ln/>
-        </p:spPr>
-      </p:sp>
-      <p:sp>
-        <p:nvSpPr>
-          <p:cNvPr id="41" name=""/>
-          <p:cNvSpPr/>
-          <p:nvPr/>
-        </p:nvSpPr>
-        <p:spPr>
-          <a:xfrm>
-            <a:off x="10715625" y="1371600"/>
-            <a:ext cx="466725" cy="447675"/>
-          </a:xfrm>
-          <a:custGeom>
-            <a:avLst/>
-            <a:gdLst/>
-            <a:ahLst/>
-            <a:cxnLst/>
-            <a:rect l="l" t="t" r="r" b="b"/>
-            <a:pathLst>
-              <a:path w="466725" h="447675">
-                <a:moveTo>
-                  <a:pt x="235268" y="0"/>
-                </a:moveTo>
-                <a:lnTo>
-                  <a:pt x="300990" y="157163"/>
-                </a:lnTo>
-                <a:lnTo>
-                  <a:pt x="470535" y="171450"/>
-                </a:lnTo>
-                <a:lnTo>
-                  <a:pt x="340995" y="281940"/>
-                </a:lnTo>
-                <a:lnTo>
-                  <a:pt x="381000" y="447675"/>
-                </a:lnTo>
-                <a:lnTo>
-                  <a:pt x="235268" y="359092"/>
-                </a:lnTo>
-                <a:lnTo>
-                  <a:pt x="89535" y="447675"/>
-                </a:lnTo>
-                <a:lnTo>
-                  <a:pt x="129540" y="281940"/>
-                </a:lnTo>
-                <a:lnTo>
-                  <a:pt x="0" y="171450"/>
-                </a:lnTo>
-                <a:lnTo>
-                  <a:pt x="169545" y="157163"/>
-                </a:lnTo>
-                <a:close/>
-              </a:path>
-            </a:pathLst>
-          </a:custGeom>
-          <a:solidFill>
-            <a:srgbClr val="FFD966"/>
-          </a:solidFill>
-          <a:ln/>
-        </p:spPr>
-      </p:sp>
-      <p:sp>
-        <p:nvSpPr>
-          <p:cNvPr id="42" name=""/>
-          <p:cNvSpPr/>
-          <p:nvPr/>
-        </p:nvSpPr>
-        <p:spPr>
-          <a:xfrm>
-            <a:off x="8058150" y="2371725"/>
-            <a:ext cx="238125" cy="228600"/>
-          </a:xfrm>
-          <a:custGeom>
-            <a:avLst/>
-            <a:gdLst/>
-            <a:ahLst/>
-            <a:cxnLst/>
-            <a:rect l="l" t="t" r="r" b="b"/>
-            <a:pathLst>
-              <a:path w="238125" h="228600">
-                <a:moveTo>
-                  <a:pt x="118110" y="0"/>
-                </a:moveTo>
-                <a:lnTo>
-                  <a:pt x="150495" y="79058"/>
-                </a:lnTo>
-                <a:lnTo>
-                  <a:pt x="236220" y="85725"/>
-                </a:lnTo>
-                <a:lnTo>
-                  <a:pt x="171450" y="140970"/>
-                </a:lnTo>
-                <a:lnTo>
-                  <a:pt x="190500" y="223838"/>
-                </a:lnTo>
-                <a:lnTo>
-                  <a:pt x="118110" y="180022"/>
-                </a:lnTo>
-                <a:lnTo>
-                  <a:pt x="45720" y="223838"/>
-                </a:lnTo>
-                <a:lnTo>
-                  <a:pt x="64770" y="140970"/>
-                </a:lnTo>
-                <a:lnTo>
-                  <a:pt x="0" y="85725"/>
-                </a:lnTo>
-                <a:lnTo>
-                  <a:pt x="85725" y="79058"/>
-                </a:lnTo>
-                <a:close/>
-              </a:path>
-            </a:pathLst>
-          </a:custGeom>
-          <a:solidFill>
-            <a:srgbClr val="FFD966"/>
-          </a:solidFill>
-          <a:ln/>
-        </p:spPr>
-      </p:sp>
-      <p:sp>
-        <p:nvSpPr>
-          <p:cNvPr id="43" name=""/>
-          <p:cNvSpPr/>
-          <p:nvPr/>
-        </p:nvSpPr>
-        <p:spPr>
-          <a:xfrm>
-            <a:off x="8258175" y="1247775"/>
-            <a:ext cx="323850" cy="323850"/>
-          </a:xfrm>
-          <a:custGeom>
-            <a:avLst/>
-            <a:gdLst/>
-            <a:ahLst/>
-            <a:cxnLst/>
-            <a:rect l="l" t="t" r="r" b="b"/>
-            <a:pathLst>
-              <a:path w="323850" h="323850">
-                <a:moveTo>
-                  <a:pt x="161925" y="0"/>
-                </a:moveTo>
-                <a:cubicBezTo>
-                  <a:pt x="184785" y="139065"/>
-                  <a:pt x="184785" y="139065"/>
-                  <a:pt x="323850" y="161925"/>
-                </a:cubicBezTo>
-                <a:cubicBezTo>
-                  <a:pt x="184785" y="184785"/>
-                  <a:pt x="184785" y="184785"/>
-                  <a:pt x="161925" y="323850"/>
-                </a:cubicBezTo>
-                <a:cubicBezTo>
-                  <a:pt x="139065" y="184785"/>
-                  <a:pt x="139065" y="184785"/>
-                  <a:pt x="0" y="161925"/>
-                </a:cubicBezTo>
-                <a:cubicBezTo>
-                  <a:pt x="139065" y="139065"/>
-                  <a:pt x="139065" y="139065"/>
-                  <a:pt x="161925" y="0"/>
-                </a:cubicBezTo>
-                <a:close/>
-              </a:path>
-            </a:pathLst>
-          </a:custGeom>
-          <a:solidFill>
-            <a:srgbClr val="FFFFFF"/>
-          </a:solidFill>
-          <a:ln/>
-        </p:spPr>
-      </p:sp>
-      <p:sp>
-        <p:nvSpPr>
-          <p:cNvPr id="44" name=""/>
-          <p:cNvSpPr/>
-          <p:nvPr/>
-        </p:nvSpPr>
-        <p:spPr>
-          <a:xfrm>
-            <a:off x="11696700" y="2552700"/>
-            <a:ext cx="228600" cy="228600"/>
-          </a:xfrm>
-          <a:custGeom>
-            <a:avLst/>
-            <a:gdLst/>
-            <a:ahLst/>
-            <a:cxnLst/>
-            <a:rect l="l" t="t" r="r" b="b"/>
-            <a:pathLst>
-              <a:path w="228600" h="228600">
-                <a:moveTo>
-                  <a:pt x="114300" y="0"/>
-                </a:moveTo>
-                <a:cubicBezTo>
-                  <a:pt x="130493" y="98108"/>
-                  <a:pt x="130493" y="98108"/>
-                  <a:pt x="228600" y="114300"/>
-                </a:cubicBezTo>
-                <a:cubicBezTo>
-                  <a:pt x="130493" y="130492"/>
-                  <a:pt x="130493" y="130492"/>
-                  <a:pt x="114300" y="228600"/>
-                </a:cubicBezTo>
-                <a:cubicBezTo>
-                  <a:pt x="98107" y="130492"/>
-                  <a:pt x="98107" y="130492"/>
-                  <a:pt x="0" y="114300"/>
-                </a:cubicBezTo>
-                <a:cubicBezTo>
-                  <a:pt x="98107" y="98108"/>
-                  <a:pt x="98107" y="98108"/>
-                  <a:pt x="114300" y="0"/>
-                </a:cubicBezTo>
-                <a:close/>
-              </a:path>
-            </a:pathLst>
-          </a:custGeom>
-          <a:solidFill>
-            <a:srgbClr val="FFFFFF"/>
-          </a:solidFill>
-          <a:ln/>
-        </p:spPr>
-      </p:sp>
-      <p:sp>
-        <p:nvSpPr>
-          <p:cNvPr id="45" name=""/>
-          <p:cNvSpPr/>
-          <p:nvPr/>
-        </p:nvSpPr>
-        <p:spPr>
-          <a:xfrm>
-            <a:off x="7219950" y="5219700"/>
-            <a:ext cx="228600" cy="228600"/>
-          </a:xfrm>
-          <a:custGeom>
-            <a:avLst/>
-            <a:gdLst/>
-            <a:ahLst/>
-            <a:cxnLst/>
-            <a:rect l="l" t="t" r="r" b="b"/>
-            <a:pathLst>
-              <a:path w="228600" h="228600">
-                <a:moveTo>
-                  <a:pt x="114300" y="0"/>
-                </a:moveTo>
-                <a:cubicBezTo>
-                  <a:pt x="130493" y="98107"/>
-                  <a:pt x="130493" y="98107"/>
-                  <a:pt x="228600" y="114300"/>
-                </a:cubicBezTo>
-                <a:cubicBezTo>
-                  <a:pt x="130493" y="130493"/>
-                  <a:pt x="130493" y="130493"/>
-                  <a:pt x="114300" y="228600"/>
-                </a:cubicBezTo>
-                <a:cubicBezTo>
-                  <a:pt x="98107" y="130493"/>
-                  <a:pt x="98107" y="130493"/>
-                  <a:pt x="0" y="114300"/>
-                </a:cubicBezTo>
-                <a:cubicBezTo>
-                  <a:pt x="98107" y="98107"/>
-                  <a:pt x="98107" y="98107"/>
-                  <a:pt x="114300" y="0"/>
-                </a:cubicBezTo>
-                <a:close/>
-              </a:path>
-            </a:pathLst>
-          </a:custGeom>
-          <a:solidFill>
-            <a:srgbClr val="FFD966"/>
           </a:solidFill>
           <a:ln/>
         </p:spPr>
@@ -23038,14 +22288,9 @@
             </a:avLst>
           </a:prstGeom>
           <a:solidFill>
-            <a:srgbClr val="FFE3EA"/>
-          </a:solidFill>
-          <a:ln w="57150">
-            <a:solidFill>
-              <a:srgbClr val="FFFFFF"/>
-            </a:solidFill>
-            <a:prstDash val="solid"/>
-          </a:ln>
+            <a:srgbClr val="FFFFFF"/>
+          </a:solidFill>
+          <a:ln/>
           <a:effectLst>
             <a:outerShdw sx="100000" sy="100000" kx="0" ky="0" algn="bl" rotWithShape="0" blurRad="152400" dist="50800" dir="5400000">
               <a:srgbClr val="22304A">
@@ -23055,235 +22300,208 @@
           </a:effectLst>
         </p:spPr>
       </p:sp>
-      <p:sp>
-        <p:nvSpPr>
-          <p:cNvPr id="9" name=""/>
-          <p:cNvSpPr/>
-          <p:nvPr/>
-        </p:nvSpPr>
-        <p:spPr>
-          <a:xfrm>
-            <a:off x="2133600" y="2362200"/>
-            <a:ext cx="1143000" cy="1143000"/>
-          </a:xfrm>
-          <a:prstGeom prst="ellipse">
-            <a:avLst/>
-          </a:prstGeom>
-          <a:solidFill>
-            <a:srgbClr val="FFB8C9"/>
-          </a:solidFill>
-          <a:ln/>
-        </p:spPr>
-      </p:sp>
+      <p:pic>
+        <p:nvPicPr>
+          <p:cNvPr id="9" name="Image 0" descr="Scott先生">    </p:cNvPr>
+          <p:cNvPicPr>
+            <a:picLocks noChangeAspect="1"/>
+          </p:cNvPicPr>
+          <p:nvPr/>
+        </p:nvPicPr>
+        <p:blipFill>
+          <a:blip r:embed="rId1"/>
+          <a:stretch>
+            <a:fillRect/>
+          </a:stretch>
+        </p:blipFill>
+        <p:spPr>
+          <a:xfrm>
+            <a:off x="666750" y="1543050"/>
+            <a:ext cx="4076700" cy="4076700"/>
+          </a:xfrm>
+          <a:prstGeom prst="rect">
+            <a:avLst/>
+          </a:prstGeom>
+        </p:spPr>
+      </p:pic>
       <p:sp>
         <p:nvSpPr>
           <p:cNvPr id="10" name=""/>
-          <p:cNvSpPr/>
-          <p:nvPr/>
-        </p:nvSpPr>
-        <p:spPr>
-          <a:xfrm>
-            <a:off x="1657350" y="3638550"/>
-            <a:ext cx="2095500" cy="1143000"/>
+          <p:cNvSpPr txBox="1"/>
+          <p:nvPr/>
+        </p:nvSpPr>
+        <p:spPr>
+          <a:xfrm>
+            <a:off x="5295900" y="1181100"/>
+            <a:ext cx="2581275" cy="523875"/>
+          </a:xfrm>
+          <a:prstGeom prst="rect">
+            <a:avLst/>
+          </a:prstGeom>
+          <a:noFill/>
+          <a:ln/>
+        </p:spPr>
+        <p:txBody>
+          <a:bodyPr wrap="square" lIns="0" tIns="0" rIns="0" bIns="0" anchor="ctr"/>
+          <a:lstStyle/>
+          <a:p>
+            <a:pPr/>
+            <a:r>
+              <a:rPr sz="3300" b="1">
+                <a:solidFill>
+                  <a:srgbClr val="C23B12"/>
+                </a:solidFill>
+                <a:latin typeface="Caveat"/>
+                <a:ea typeface="Caveat"/>
+              </a:rPr>
+              <a:t>Hi, I'm Scott!</a:t>
+            </a:r>
+          </a:p>
+        </p:txBody>
+      </p:sp>
+      <p:sp>
+        <p:nvSpPr>
+          <p:cNvPr id="11" name=""/>
+          <p:cNvSpPr txBox="1"/>
+          <p:nvPr/>
+        </p:nvSpPr>
+        <p:spPr>
+          <a:xfrm>
+            <a:off x="5295900" y="1600200"/>
+            <a:ext cx="3819525" cy="952500"/>
+          </a:xfrm>
+          <a:prstGeom prst="rect">
+            <a:avLst/>
+          </a:prstGeom>
+          <a:noFill/>
+          <a:ln/>
+        </p:spPr>
+        <p:txBody>
+          <a:bodyPr wrap="square" lIns="0" tIns="0" rIns="0" bIns="0" anchor="ctr"/>
+          <a:lstStyle/>
+          <a:p>
+            <a:pPr/>
+            <a:r>
+              <a:rPr sz="5100" b="1">
+                <a:solidFill>
+                  <a:srgbClr val="1A2238"/>
+                </a:solidFill>
+                <a:latin typeface="DM Sans"/>
+                <a:ea typeface="DM Sans"/>
+              </a:rPr>
+              <a:t>Scott</a:t>
+            </a:r>
+            <a:pPr/>
+            <a:r>
+              <a:rPr sz="5100" b="1">
+                <a:solidFill>
+                  <a:srgbClr val="1A2238"/>
+                </a:solidFill>
+                <a:latin typeface="Noto Sans JP"/>
+                <a:ea typeface="Noto Sans JP"/>
+              </a:rPr>
+              <a:t>先生</a:t>
+            </a:r>
+          </a:p>
+        </p:txBody>
+      </p:sp>
+      <p:pic>
+        <p:nvPicPr>
+          <p:cNvPr id="12" name="Image 1" descr="カナダの国旗">    </p:cNvPr>
+          <p:cNvPicPr>
+            <a:picLocks noChangeAspect="1"/>
+          </p:cNvPicPr>
+          <p:nvPr/>
+        </p:nvPicPr>
+        <p:blipFill>
+          <a:blip r:embed="rId2"/>
+          <a:stretch>
+            <a:fillRect/>
+          </a:stretch>
+        </p:blipFill>
+        <p:spPr>
+          <a:xfrm>
+            <a:off x="8524875" y="1952625"/>
+            <a:ext cx="609600" cy="304800"/>
+          </a:xfrm>
+          <a:prstGeom prst="rect">
+            <a:avLst/>
+          </a:prstGeom>
+        </p:spPr>
+      </p:pic>
+      <p:sp>
+        <p:nvSpPr>
+          <p:cNvPr id="13" name=""/>
+          <p:cNvSpPr txBox="1"/>
+          <p:nvPr/>
+        </p:nvSpPr>
+        <p:spPr>
+          <a:xfrm>
+            <a:off x="9210675" y="1962150"/>
+            <a:ext cx="561975" cy="276225"/>
+          </a:xfrm>
+          <a:prstGeom prst="rect">
+            <a:avLst/>
+          </a:prstGeom>
+          <a:noFill/>
+          <a:ln/>
+        </p:spPr>
+        <p:txBody>
+          <a:bodyPr wrap="square" lIns="0" tIns="0" rIns="0" bIns="0" anchor="ctr"/>
+          <a:lstStyle/>
+          <a:p>
+            <a:pPr/>
+            <a:r>
+              <a:rPr sz="1500" b="1">
+                <a:solidFill>
+                  <a:srgbClr val="5E6780"/>
+                </a:solidFill>
+                <a:latin typeface="Noto Sans JP"/>
+                <a:ea typeface="Noto Sans JP"/>
+              </a:rPr>
+              <a:t>→</a:t>
+            </a:r>
+          </a:p>
+        </p:txBody>
+      </p:sp>
+      <p:pic>
+        <p:nvPicPr>
+          <p:cNvPr id="14" name="Image 2" descr="アメリカの国旗">    </p:cNvPr>
+          <p:cNvPicPr>
+            <a:picLocks noChangeAspect="1"/>
+          </p:cNvPicPr>
+          <p:nvPr/>
+        </p:nvPicPr>
+        <p:blipFill>
+          <a:blip r:embed="rId3"/>
+          <a:stretch>
+            <a:fillRect/>
+          </a:stretch>
+        </p:blipFill>
+        <p:spPr>
+          <a:xfrm>
+            <a:off x="9477375" y="1952625"/>
+            <a:ext cx="581025" cy="304800"/>
+          </a:xfrm>
+          <a:prstGeom prst="rect">
+            <a:avLst/>
+          </a:prstGeom>
+        </p:spPr>
+      </p:pic>
+      <p:sp>
+        <p:nvSpPr>
+          <p:cNvPr id="15" name=""/>
+          <p:cNvSpPr/>
+          <p:nvPr/>
+        </p:nvSpPr>
+        <p:spPr>
+          <a:xfrm>
+            <a:off x="5295900" y="2676525"/>
+            <a:ext cx="6286500" cy="3267075"/>
           </a:xfrm>
           <a:prstGeom prst="roundRect">
             <a:avLst>
-              <a:gd name="adj" fmla="val 50000"/>
-            </a:avLst>
-          </a:prstGeom>
-          <a:solidFill>
-            <a:srgbClr val="FFB8C9"/>
-          </a:solidFill>
-          <a:ln/>
-        </p:spPr>
-      </p:sp>
-      <p:sp>
-        <p:nvSpPr>
-          <p:cNvPr id="11" name=""/>
-          <p:cNvSpPr txBox="1"/>
-          <p:nvPr/>
-        </p:nvSpPr>
-        <p:spPr>
-          <a:xfrm>
-            <a:off x="1847850" y="5048250"/>
-            <a:ext cx="1724025" cy="247650"/>
-          </a:xfrm>
-          <a:prstGeom prst="rect">
-            <a:avLst/>
-          </a:prstGeom>
-          <a:noFill/>
-          <a:ln/>
-        </p:spPr>
-        <p:txBody>
-          <a:bodyPr wrap="square" lIns="0" tIns="0" rIns="0" bIns="0" anchor="ctr"/>
-          <a:lstStyle/>
-          <a:p>
-            <a:pPr algn="ctr"/>
-            <a:r>
-              <a:rPr sz="1350" b="1">
-                <a:solidFill>
-                  <a:srgbClr val="C2416A"/>
-                </a:solidFill>
-                <a:latin typeface="Noto Sans JP"/>
-                <a:ea typeface="Noto Sans JP"/>
-              </a:rPr>
-              <a:t>写真が入ります</a:t>
-            </a:r>
-          </a:p>
-        </p:txBody>
-      </p:sp>
-      <p:sp>
-        <p:nvSpPr>
-          <p:cNvPr id="12" name=""/>
-          <p:cNvSpPr/>
-          <p:nvPr/>
-        </p:nvSpPr>
-        <p:spPr>
-          <a:xfrm>
-            <a:off x="5334000" y="1666875"/>
-            <a:ext cx="1362075" cy="304800"/>
-          </a:xfrm>
-          <a:prstGeom prst="roundRect">
-            <a:avLst>
-              <a:gd name="adj" fmla="val 50000"/>
-            </a:avLst>
-          </a:prstGeom>
-          <a:solidFill>
-            <a:srgbClr val="FFE6DC"/>
-          </a:solidFill>
-          <a:ln/>
-        </p:spPr>
-      </p:sp>
-      <p:sp>
-        <p:nvSpPr>
-          <p:cNvPr id="13" name=""/>
-          <p:cNvSpPr txBox="1"/>
-          <p:nvPr/>
-        </p:nvSpPr>
-        <p:spPr>
-          <a:xfrm>
-            <a:off x="5467350" y="1714500"/>
-            <a:ext cx="1600200" cy="200025"/>
-          </a:xfrm>
-          <a:prstGeom prst="rect">
-            <a:avLst/>
-          </a:prstGeom>
-          <a:noFill/>
-          <a:ln/>
-        </p:spPr>
-        <p:txBody>
-          <a:bodyPr wrap="square" lIns="0" tIns="0" rIns="0" bIns="0" anchor="ctr"/>
-          <a:lstStyle/>
-          <a:p>
-            <a:pPr/>
-            <a:r>
-              <a:rPr sz="1150" b="1">
-                <a:solidFill>
-                  <a:srgbClr val="C23B12"/>
-                </a:solidFill>
-                <a:latin typeface="Noto Sans JP"/>
-                <a:ea typeface="Noto Sans JP"/>
-              </a:rPr>
-              <a:t>SPECIAL GUEST</a:t>
-            </a:r>
-          </a:p>
-        </p:txBody>
-      </p:sp>
-      <p:sp>
-        <p:nvSpPr>
-          <p:cNvPr id="14" name=""/>
-          <p:cNvSpPr txBox="1"/>
-          <p:nvPr/>
-        </p:nvSpPr>
-        <p:spPr>
-          <a:xfrm>
-            <a:off x="5334000" y="2085975"/>
-            <a:ext cx="2581275" cy="523875"/>
-          </a:xfrm>
-          <a:prstGeom prst="rect">
-            <a:avLst/>
-          </a:prstGeom>
-          <a:noFill/>
-          <a:ln/>
-        </p:spPr>
-        <p:txBody>
-          <a:bodyPr wrap="square" lIns="0" tIns="0" rIns="0" bIns="0" anchor="ctr"/>
-          <a:lstStyle/>
-          <a:p>
-            <a:pPr/>
-            <a:r>
-              <a:rPr sz="3300" b="1">
-                <a:solidFill>
-                  <a:srgbClr val="C23B12"/>
-                </a:solidFill>
-                <a:latin typeface="Caveat"/>
-                <a:ea typeface="Caveat"/>
-              </a:rPr>
-              <a:t>Hi, I'm Scott!</a:t>
-            </a:r>
-          </a:p>
-        </p:txBody>
-      </p:sp>
-      <p:sp>
-        <p:nvSpPr>
-          <p:cNvPr id="15" name=""/>
-          <p:cNvSpPr txBox="1"/>
-          <p:nvPr/>
-        </p:nvSpPr>
-        <p:spPr>
-          <a:xfrm>
-            <a:off x="5334000" y="2514600"/>
-            <a:ext cx="4019550" cy="1009650"/>
-          </a:xfrm>
-          <a:prstGeom prst="rect">
-            <a:avLst/>
-          </a:prstGeom>
-          <a:noFill/>
-          <a:ln/>
-        </p:spPr>
-        <p:txBody>
-          <a:bodyPr wrap="square" lIns="0" tIns="0" rIns="0" bIns="0" anchor="ctr"/>
-          <a:lstStyle/>
-          <a:p>
-            <a:pPr/>
-            <a:r>
-              <a:rPr sz="5400" b="1">
-                <a:solidFill>
-                  <a:srgbClr val="1A2238"/>
-                </a:solidFill>
-                <a:latin typeface="DM Sans"/>
-                <a:ea typeface="DM Sans"/>
-              </a:rPr>
-              <a:t>Scott</a:t>
-            </a:r>
-            <a:pPr/>
-            <a:r>
-              <a:rPr sz="5400" b="1">
-                <a:solidFill>
-                  <a:srgbClr val="1A2238"/>
-                </a:solidFill>
-                <a:latin typeface="Noto Sans JP"/>
-                <a:ea typeface="Noto Sans JP"/>
-              </a:rPr>
-              <a:t>先生</a:t>
-            </a:r>
-          </a:p>
-        </p:txBody>
-      </p:sp>
-      <p:sp>
-        <p:nvSpPr>
-          <p:cNvPr id="16" name=""/>
-          <p:cNvSpPr/>
-          <p:nvPr/>
-        </p:nvSpPr>
-        <p:spPr>
-          <a:xfrm>
-            <a:off x="5334000" y="3714750"/>
-            <a:ext cx="6248400" cy="1781175"/>
-          </a:xfrm>
-          <a:prstGeom prst="roundRect">
-            <a:avLst>
-              <a:gd name="adj" fmla="val 11765"/>
+              <a:gd name="adj" fmla="val 6414"/>
             </a:avLst>
           </a:prstGeom>
           <a:solidFill>
@@ -23301,13 +22519,13 @@
       </p:sp>
       <p:sp>
         <p:nvSpPr>
-          <p:cNvPr id="17" name=""/>
-          <p:cNvSpPr txBox="1"/>
-          <p:nvPr/>
-        </p:nvSpPr>
-        <p:spPr>
-          <a:xfrm>
-            <a:off x="5600700" y="3943350"/>
+          <p:cNvPr id="16" name=""/>
+          <p:cNvSpPr txBox="1"/>
+          <p:nvPr/>
+        </p:nvSpPr>
+        <p:spPr>
+          <a:xfrm>
+            <a:off x="5562600" y="2943225"/>
             <a:ext cx="676275" cy="200025"/>
           </a:xfrm>
           <a:prstGeom prst="rect">
@@ -23336,35 +22554,70 @@
       </p:sp>
       <p:sp>
         <p:nvSpPr>
+          <p:cNvPr id="17" name=""/>
+          <p:cNvSpPr txBox="1"/>
+          <p:nvPr/>
+        </p:nvSpPr>
+        <p:spPr>
+          <a:xfrm>
+            <a:off x="6477000" y="2809875"/>
+            <a:ext cx="4924425" cy="266700"/>
+          </a:xfrm>
+          <a:prstGeom prst="rect">
+            <a:avLst/>
+          </a:prstGeom>
+          <a:noFill/>
+          <a:ln/>
+        </p:spPr>
+        <p:txBody>
+          <a:bodyPr wrap="square" lIns="0" tIns="0" rIns="0" bIns="0" anchor="ctr"/>
+          <a:lstStyle/>
+          <a:p>
+            <a:pPr/>
+            <a:r>
+              <a:rPr sz="1600" b="1">
+                <a:solidFill>
+                  <a:srgbClr val="1A2238"/>
+                </a:solidFill>
+                <a:latin typeface="DM Sans"/>
+                <a:ea typeface="DM Sans"/>
+              </a:rPr>
+              <a:t>Born in Canada, grew up mostly in the US</a:t>
+            </a:r>
+          </a:p>
+        </p:txBody>
+      </p:sp>
+      <p:sp>
+        <p:nvSpPr>
           <p:cNvPr id="18" name=""/>
           <p:cNvSpPr txBox="1"/>
           <p:nvPr/>
         </p:nvSpPr>
         <p:spPr>
           <a:xfrm>
-            <a:off x="6648450" y="3905250"/>
-            <a:ext cx="2305050" cy="276225"/>
-          </a:xfrm>
-          <a:prstGeom prst="rect">
-            <a:avLst/>
-          </a:prstGeom>
-          <a:noFill/>
-          <a:ln/>
-        </p:spPr>
-        <p:txBody>
-          <a:bodyPr wrap="square" lIns="0" tIns="0" rIns="0" bIns="0" anchor="ctr"/>
-          <a:lstStyle/>
-          <a:p>
-            <a:pPr/>
-            <a:r>
-              <a:rPr sz="1500" b="1">
+            <a:off x="6477000" y="3086100"/>
+            <a:ext cx="2638425" cy="190500"/>
+          </a:xfrm>
+          <a:prstGeom prst="rect">
+            <a:avLst/>
+          </a:prstGeom>
+          <a:noFill/>
+          <a:ln/>
+        </p:spPr>
+        <p:txBody>
+          <a:bodyPr wrap="square" lIns="0" tIns="0" rIns="0" bIns="0" anchor="ctr"/>
+          <a:lstStyle/>
+          <a:p>
+            <a:pPr/>
+            <a:r>
+              <a:rPr sz="1050" b="1">
                 <a:solidFill>
                   <a:srgbClr val="5E6780"/>
                 </a:solidFill>
                 <a:latin typeface="Noto Sans JP"/>
                 <a:ea typeface="Noto Sans JP"/>
               </a:rPr>
-              <a:t>（あとで入れます）</a:t>
+              <a:t>カナダ生まれ、ほぼアメリカ育ち</a:t>
             </a:r>
           </a:p>
         </p:txBody>
@@ -23377,8 +22630,8 @@
         </p:nvSpPr>
         <p:spPr>
           <a:xfrm>
-            <a:off x="5600700" y="4324350"/>
-            <a:ext cx="5715000" cy="0"/>
+            <a:off x="5562600" y="3381375"/>
+            <a:ext cx="5753100" cy="0"/>
           </a:xfrm>
           <a:prstGeom prst="line">
             <a:avLst/>
@@ -23400,7 +22653,7 @@
         </p:nvSpPr>
         <p:spPr>
           <a:xfrm>
-            <a:off x="5600700" y="4505325"/>
+            <a:off x="5562600" y="3629025"/>
             <a:ext cx="676275" cy="200025"/>
           </a:xfrm>
           <a:prstGeom prst="rect">
@@ -23422,7 +22675,7 @@
                 <a:latin typeface="Noto Sans JP"/>
                 <a:ea typeface="Noto Sans JP"/>
               </a:rPr>
-              <a:t>経歴</a:t>
+              <a:t>来日</a:t>
             </a:r>
           </a:p>
         </p:txBody>
@@ -23435,29 +22688,40 @@
         </p:nvSpPr>
         <p:spPr>
           <a:xfrm>
-            <a:off x="6648450" y="4467225"/>
-            <a:ext cx="2305050" cy="276225"/>
-          </a:xfrm>
-          <a:prstGeom prst="rect">
-            <a:avLst/>
-          </a:prstGeom>
-          <a:noFill/>
-          <a:ln/>
-        </p:spPr>
-        <p:txBody>
-          <a:bodyPr wrap="square" lIns="0" tIns="0" rIns="0" bIns="0" anchor="ctr"/>
-          <a:lstStyle/>
-          <a:p>
-            <a:pPr/>
-            <a:r>
-              <a:rPr sz="1500" b="1">
-                <a:solidFill>
-                  <a:srgbClr val="5E6780"/>
+            <a:off x="6477000" y="3514725"/>
+            <a:ext cx="5391150" cy="266700"/>
+          </a:xfrm>
+          <a:prstGeom prst="rect">
+            <a:avLst/>
+          </a:prstGeom>
+          <a:noFill/>
+          <a:ln/>
+        </p:spPr>
+        <p:txBody>
+          <a:bodyPr wrap="square" lIns="0" tIns="0" rIns="0" bIns="0" anchor="ctr"/>
+          <a:lstStyle/>
+          <a:p>
+            <a:pPr/>
+            <a:r>
+              <a:rPr sz="1600" b="1">
+                <a:solidFill>
+                  <a:srgbClr val="1A2238"/>
+                </a:solidFill>
+                <a:latin typeface="DM Sans"/>
+                <a:ea typeface="DM Sans"/>
+              </a:rPr>
+              <a:t>Came to Japan to study martial arts and </a:t>
+            </a:r>
+            <a:pPr/>
+            <a:r>
+              <a:rPr sz="1600" b="1">
+                <a:solidFill>
+                  <a:srgbClr val="1A2238"/>
                 </a:solidFill>
                 <a:latin typeface="Noto Sans JP"/>
                 <a:ea typeface="Noto Sans JP"/>
               </a:rPr>
-              <a:t>（あとで入れます）</a:t>
+              <a:t>整体</a:t>
             </a:r>
           </a:p>
         </p:txBody>
@@ -23465,13 +22729,48 @@
       <p:sp>
         <p:nvSpPr>
           <p:cNvPr id="22" name=""/>
-          <p:cNvSpPr/>
-          <p:nvPr/>
-        </p:nvSpPr>
-        <p:spPr>
-          <a:xfrm>
-            <a:off x="5600700" y="4886325"/>
-            <a:ext cx="5715000" cy="0"/>
+          <p:cNvSpPr txBox="1"/>
+          <p:nvPr/>
+        </p:nvSpPr>
+        <p:spPr>
+          <a:xfrm>
+            <a:off x="6477000" y="3790950"/>
+            <a:ext cx="2181225" cy="190500"/>
+          </a:xfrm>
+          <a:prstGeom prst="rect">
+            <a:avLst/>
+          </a:prstGeom>
+          <a:noFill/>
+          <a:ln/>
+        </p:spPr>
+        <p:txBody>
+          <a:bodyPr wrap="square" lIns="0" tIns="0" rIns="0" bIns="0" anchor="ctr"/>
+          <a:lstStyle/>
+          <a:p>
+            <a:pPr/>
+            <a:r>
+              <a:rPr sz="1050" b="1">
+                <a:solidFill>
+                  <a:srgbClr val="5E6780"/>
+                </a:solidFill>
+                <a:latin typeface="Noto Sans JP"/>
+                <a:ea typeface="Noto Sans JP"/>
+              </a:rPr>
+              <a:t>武道と整体を学びに日本へ</a:t>
+            </a:r>
+          </a:p>
+        </p:txBody>
+      </p:sp>
+      <p:sp>
+        <p:nvSpPr>
+          <p:cNvPr id="23" name=""/>
+          <p:cNvSpPr/>
+          <p:nvPr/>
+        </p:nvSpPr>
+        <p:spPr>
+          <a:xfrm>
+            <a:off x="5562600" y="4086225"/>
+            <a:ext cx="5753100" cy="0"/>
           </a:xfrm>
           <a:prstGeom prst="line">
             <a:avLst/>
@@ -23487,14 +22786,14 @@
       </p:sp>
       <p:sp>
         <p:nvSpPr>
-          <p:cNvPr id="23" name=""/>
-          <p:cNvSpPr txBox="1"/>
-          <p:nvPr/>
-        </p:nvSpPr>
-        <p:spPr>
-          <a:xfrm>
-            <a:off x="5600700" y="5067300"/>
-            <a:ext cx="990600" cy="200025"/>
+          <p:cNvPr id="24" name=""/>
+          <p:cNvSpPr txBox="1"/>
+          <p:nvPr/>
+        </p:nvSpPr>
+        <p:spPr>
+          <a:xfrm>
+            <a:off x="5562600" y="4324350"/>
+            <a:ext cx="676275" cy="200025"/>
           </a:xfrm>
           <a:prstGeom prst="rect">
             <a:avLst/>
@@ -23515,49 +22814,305 @@
                 <a:latin typeface="Noto Sans JP"/>
                 <a:ea typeface="Noto Sans JP"/>
               </a:rPr>
-              <a:t>ひとこと</a:t>
-            </a:r>
-          </a:p>
-        </p:txBody>
-      </p:sp>
-      <p:sp>
-        <p:nvSpPr>
-          <p:cNvPr id="24" name=""/>
-          <p:cNvSpPr txBox="1"/>
-          <p:nvPr/>
-        </p:nvSpPr>
-        <p:spPr>
-          <a:xfrm>
-            <a:off x="6648450" y="5029200"/>
-            <a:ext cx="2305050" cy="276225"/>
-          </a:xfrm>
-          <a:prstGeom prst="rect">
-            <a:avLst/>
-          </a:prstGeom>
-          <a:noFill/>
-          <a:ln/>
-        </p:spPr>
-        <p:txBody>
-          <a:bodyPr wrap="square" lIns="0" tIns="0" rIns="0" bIns="0" anchor="ctr"/>
-          <a:lstStyle/>
-          <a:p>
-            <a:pPr/>
-            <a:r>
-              <a:rPr sz="1500" b="1">
+              <a:t>経歴</a:t>
+            </a:r>
+          </a:p>
+        </p:txBody>
+      </p:sp>
+      <p:sp>
+        <p:nvSpPr>
+          <p:cNvPr id="25" name=""/>
+          <p:cNvSpPr txBox="1"/>
+          <p:nvPr/>
+        </p:nvSpPr>
+        <p:spPr>
+          <a:xfrm>
+            <a:off x="6477000" y="4191000"/>
+            <a:ext cx="3276600" cy="266700"/>
+          </a:xfrm>
+          <a:prstGeom prst="rect">
+            <a:avLst/>
+          </a:prstGeom>
+          <a:noFill/>
+          <a:ln/>
+        </p:spPr>
+        <p:txBody>
+          <a:bodyPr wrap="square" lIns="0" tIns="0" rIns="0" bIns="0" anchor="ctr"/>
+          <a:lstStyle/>
+          <a:p>
+            <a:pPr/>
+            <a:r>
+              <a:rPr sz="1600" b="1">
+                <a:solidFill>
+                  <a:srgbClr val="1A2238"/>
+                </a:solidFill>
+                <a:latin typeface="DM Sans"/>
+                <a:ea typeface="DM Sans"/>
+              </a:rPr>
+              <a:t>Teaching for over 35 years</a:t>
+            </a:r>
+          </a:p>
+        </p:txBody>
+      </p:sp>
+      <p:sp>
+        <p:nvSpPr>
+          <p:cNvPr id="26" name=""/>
+          <p:cNvSpPr txBox="1"/>
+          <p:nvPr/>
+        </p:nvSpPr>
+        <p:spPr>
+          <a:xfrm>
+            <a:off x="6477000" y="4467225"/>
+            <a:ext cx="2047875" cy="190500"/>
+          </a:xfrm>
+          <a:prstGeom prst="rect">
+            <a:avLst/>
+          </a:prstGeom>
+          <a:noFill/>
+          <a:ln/>
+        </p:spPr>
+        <p:txBody>
+          <a:bodyPr wrap="square" lIns="0" tIns="0" rIns="0" bIns="0" anchor="ctr"/>
+          <a:lstStyle/>
+          <a:p>
+            <a:pPr/>
+            <a:r>
+              <a:rPr sz="1050" b="1">
                 <a:solidFill>
                   <a:srgbClr val="5E6780"/>
                 </a:solidFill>
                 <a:latin typeface="Noto Sans JP"/>
                 <a:ea typeface="Noto Sans JP"/>
               </a:rPr>
-              <a:t>（あとで入れます）</a:t>
-            </a:r>
-          </a:p>
-        </p:txBody>
-      </p:sp>
-      <p:sp>
-        <p:nvSpPr>
-          <p:cNvPr id="25" name=""/>
+              <a:t>35年以上、教えています</a:t>
+            </a:r>
+          </a:p>
+        </p:txBody>
+      </p:sp>
+      <p:sp>
+        <p:nvSpPr>
+          <p:cNvPr id="27" name=""/>
+          <p:cNvSpPr/>
+          <p:nvPr/>
+        </p:nvSpPr>
+        <p:spPr>
+          <a:xfrm>
+            <a:off x="5562600" y="4762500"/>
+            <a:ext cx="5753100" cy="0"/>
+          </a:xfrm>
+          <a:prstGeom prst="line">
+            <a:avLst/>
+          </a:prstGeom>
+          <a:noFill/>
+          <a:ln w="19050">
+            <a:solidFill>
+              <a:srgbClr val="EFE3DA"/>
+            </a:solidFill>
+            <a:prstDash val="solid"/>
+          </a:ln>
+        </p:spPr>
+      </p:sp>
+      <p:sp>
+        <p:nvSpPr>
+          <p:cNvPr id="28" name=""/>
+          <p:cNvSpPr txBox="1"/>
+          <p:nvPr/>
+        </p:nvSpPr>
+        <p:spPr>
+          <a:xfrm>
+            <a:off x="5562600" y="5000625"/>
+            <a:ext cx="676275" cy="200025"/>
+          </a:xfrm>
+          <a:prstGeom prst="rect">
+            <a:avLst/>
+          </a:prstGeom>
+          <a:noFill/>
+          <a:ln/>
+        </p:spPr>
+        <p:txBody>
+          <a:bodyPr wrap="square" lIns="0" tIns="0" rIns="0" bIns="0" anchor="ctr"/>
+          <a:lstStyle/>
+          <a:p>
+            <a:pPr/>
+            <a:r>
+              <a:rPr sz="1150" b="1">
+                <a:solidFill>
+                  <a:srgbClr val="C23B12"/>
+                </a:solidFill>
+                <a:latin typeface="Noto Sans JP"/>
+                <a:ea typeface="Noto Sans JP"/>
+              </a:rPr>
+              <a:t>在住</a:t>
+            </a:r>
+          </a:p>
+        </p:txBody>
+      </p:sp>
+      <p:sp>
+        <p:nvSpPr>
+          <p:cNvPr id="29" name=""/>
+          <p:cNvSpPr txBox="1"/>
+          <p:nvPr/>
+        </p:nvSpPr>
+        <p:spPr>
+          <a:xfrm>
+            <a:off x="6477000" y="4867275"/>
+            <a:ext cx="1933575" cy="266700"/>
+          </a:xfrm>
+          <a:prstGeom prst="rect">
+            <a:avLst/>
+          </a:prstGeom>
+          <a:noFill/>
+          <a:ln/>
+        </p:spPr>
+        <p:txBody>
+          <a:bodyPr wrap="square" lIns="0" tIns="0" rIns="0" bIns="0" anchor="ctr"/>
+          <a:lstStyle/>
+          <a:p>
+            <a:pPr/>
+            <a:r>
+              <a:rPr sz="1600" b="1">
+                <a:solidFill>
+                  <a:srgbClr val="1A2238"/>
+                </a:solidFill>
+                <a:latin typeface="DM Sans"/>
+                <a:ea typeface="DM Sans"/>
+              </a:rPr>
+              <a:t>Lives in Osaka</a:t>
+            </a:r>
+          </a:p>
+        </p:txBody>
+      </p:sp>
+      <p:sp>
+        <p:nvSpPr>
+          <p:cNvPr id="30" name=""/>
+          <p:cNvSpPr txBox="1"/>
+          <p:nvPr/>
+        </p:nvSpPr>
+        <p:spPr>
+          <a:xfrm>
+            <a:off x="6477000" y="5143500"/>
+            <a:ext cx="952500" cy="190500"/>
+          </a:xfrm>
+          <a:prstGeom prst="rect">
+            <a:avLst/>
+          </a:prstGeom>
+          <a:noFill/>
+          <a:ln/>
+        </p:spPr>
+        <p:txBody>
+          <a:bodyPr wrap="square" lIns="0" tIns="0" rIns="0" bIns="0" anchor="ctr"/>
+          <a:lstStyle/>
+          <a:p>
+            <a:pPr/>
+            <a:r>
+              <a:rPr sz="1050" b="1">
+                <a:solidFill>
+                  <a:srgbClr val="5E6780"/>
+                </a:solidFill>
+                <a:latin typeface="Noto Sans JP"/>
+                <a:ea typeface="Noto Sans JP"/>
+              </a:rPr>
+              <a:t>大阪在住</a:t>
+            </a:r>
+          </a:p>
+        </p:txBody>
+      </p:sp>
+      <p:sp>
+        <p:nvSpPr>
+          <p:cNvPr id="31" name=""/>
+          <p:cNvSpPr/>
+          <p:nvPr/>
+        </p:nvSpPr>
+        <p:spPr>
+          <a:xfrm>
+            <a:off x="5562600" y="5438775"/>
+            <a:ext cx="5753100" cy="0"/>
+          </a:xfrm>
+          <a:prstGeom prst="line">
+            <a:avLst/>
+          </a:prstGeom>
+          <a:noFill/>
+          <a:ln w="19050">
+            <a:solidFill>
+              <a:srgbClr val="EFE3DA"/>
+            </a:solidFill>
+            <a:prstDash val="solid"/>
+          </a:ln>
+        </p:spPr>
+      </p:sp>
+      <p:sp>
+        <p:nvSpPr>
+          <p:cNvPr id="32" name=""/>
+          <p:cNvSpPr txBox="1"/>
+          <p:nvPr/>
+        </p:nvSpPr>
+        <p:spPr>
+          <a:xfrm>
+            <a:off x="5562600" y="5572125"/>
+            <a:ext cx="1028700" cy="200025"/>
+          </a:xfrm>
+          <a:prstGeom prst="rect">
+            <a:avLst/>
+          </a:prstGeom>
+          <a:noFill/>
+          <a:ln/>
+        </p:spPr>
+        <p:txBody>
+          <a:bodyPr wrap="square" lIns="0" tIns="0" rIns="0" bIns="0" anchor="ctr"/>
+          <a:lstStyle/>
+          <a:p>
+            <a:pPr/>
+            <a:r>
+              <a:rPr sz="1150" b="1">
+                <a:solidFill>
+                  <a:srgbClr val="D91F26"/>
+                </a:solidFill>
+                <a:latin typeface="Noto Sans JP"/>
+                <a:ea typeface="Noto Sans JP"/>
+              </a:rPr>
+              <a:t>YouTube</a:t>
+            </a:r>
+          </a:p>
+        </p:txBody>
+      </p:sp>
+      <p:sp>
+        <p:nvSpPr>
+          <p:cNvPr id="33" name=""/>
+          <p:cNvSpPr txBox="1"/>
+          <p:nvPr/>
+        </p:nvSpPr>
+        <p:spPr>
+          <a:xfrm>
+            <a:off x="6477000" y="5543550"/>
+            <a:ext cx="1952625" cy="266700"/>
+          </a:xfrm>
+          <a:prstGeom prst="rect">
+            <a:avLst/>
+          </a:prstGeom>
+          <a:noFill/>
+          <a:ln/>
+        </p:spPr>
+        <p:txBody>
+          <a:bodyPr wrap="square" lIns="0" tIns="0" rIns="0" bIns="0" anchor="ctr"/>
+          <a:lstStyle/>
+          <a:p>
+            <a:pPr/>
+            <a:r>
+              <a:rPr sz="1600" b="1">
+                <a:solidFill>
+                  <a:srgbClr val="1A2238"/>
+                </a:solidFill>
+                <a:latin typeface="DM Sans"/>
+                <a:ea typeface="DM Sans"/>
+              </a:rPr>
+              <a:t>BananaeigoTV</a:t>
+            </a:r>
+          </a:p>
+        </p:txBody>
+      </p:sp>
+      <p:sp>
+        <p:nvSpPr>
+          <p:cNvPr id="34" name=""/>
           <p:cNvSpPr/>
           <p:nvPr/>
         </p:nvSpPr>
@@ -23598,7 +23153,7 @@
       </p:sp>
       <p:sp>
         <p:nvSpPr>
-          <p:cNvPr id="26" name=""/>
+          <p:cNvPr id="35" name=""/>
           <p:cNvSpPr/>
           <p:nvPr/>
         </p:nvSpPr>
@@ -23639,7 +23194,7 @@
       </p:sp>
       <p:sp>
         <p:nvSpPr>
-          <p:cNvPr id="27" name=""/>
+          <p:cNvPr id="36" name=""/>
           <p:cNvSpPr/>
           <p:nvPr/>
         </p:nvSpPr>
@@ -23680,7 +23235,7 @@
       </p:sp>
       <p:sp>
         <p:nvSpPr>
-          <p:cNvPr id="28" name=""/>
+          <p:cNvPr id="37" name=""/>
           <p:cNvSpPr/>
           <p:nvPr/>
         </p:nvSpPr>
@@ -45751,7 +45306,7 @@
             </a:pathLst>
           </a:custGeom>
           <a:solidFill>
-            <a:srgbClr val="F36B3D"/>
+            <a:srgbClr val="F25F2D"/>
           </a:solidFill>
           <a:ln/>
         </p:spPr>
@@ -45942,7 +45497,7 @@
             </a:avLst>
           </a:prstGeom>
           <a:solidFill>
-            <a:srgbClr val="FFD966"/>
+            <a:srgbClr val="FFFFFF"/>
           </a:solidFill>
           <a:ln/>
         </p:spPr>
@@ -45972,7 +45527,7 @@
             <a:r>
               <a:rPr sz="1500" b="1">
                 <a:solidFill>
-                  <a:srgbClr val="1A2238"/>
+                  <a:srgbClr val="C23B12"/>
                 </a:solidFill>
                 <a:latin typeface="Noto Sans JP"/>
                 <a:ea typeface="Noto Sans JP"/>
@@ -45990,53 +45545,77 @@
         </p:nvSpPr>
         <p:spPr>
           <a:xfrm>
-            <a:off x="609600" y="1343025"/>
-            <a:ext cx="7953375" cy="942975"/>
-          </a:xfrm>
-          <a:prstGeom prst="rect">
-            <a:avLst/>
-          </a:prstGeom>
-          <a:noFill/>
-          <a:ln/>
-        </p:spPr>
-        <p:txBody>
-          <a:bodyPr wrap="square" lIns="0" tIns="0" rIns="0" bIns="0" anchor="ctr"/>
-          <a:lstStyle/>
-          <a:p>
-            <a:pPr/>
-            <a:r>
-              <a:rPr sz="5700" b="1" spc="-75" kern="0">
+            <a:off x="676275" y="1352550"/>
+            <a:ext cx="9410700" cy="1266825"/>
+          </a:xfrm>
+          <a:prstGeom prst="rect">
+            <a:avLst/>
+          </a:prstGeom>
+          <a:noFill/>
+          <a:ln/>
+        </p:spPr>
+        <p:txBody>
+          <a:bodyPr wrap="square" lIns="0" tIns="0" rIns="0" bIns="0" anchor="ctr"/>
+          <a:lstStyle/>
+          <a:p>
+            <a:pPr/>
+            <a:r>
+              <a:rPr sz="6900">
+                <a:solidFill>
+                  <a:srgbClr val="A3300B"/>
+                </a:solidFill>
+                <a:latin typeface="Reggae One"/>
+                <a:ea typeface="Reggae One"/>
+              </a:rPr>
+              <a:t>チャレンジステージ</a:t>
+            </a:r>
+          </a:p>
+        </p:txBody>
+      </p:sp>
+      <p:sp>
+        <p:nvSpPr>
+          <p:cNvPr id="12" name=""/>
+          <p:cNvSpPr txBox="1"/>
+          <p:nvPr/>
+        </p:nvSpPr>
+        <p:spPr>
+          <a:xfrm>
+            <a:off x="609600" y="1285875"/>
+            <a:ext cx="9410700" cy="1266825"/>
+          </a:xfrm>
+          <a:prstGeom prst="rect">
+            <a:avLst/>
+          </a:prstGeom>
+          <a:noFill/>
+          <a:ln/>
+        </p:spPr>
+        <p:txBody>
+          <a:bodyPr wrap="square" lIns="0" tIns="0" rIns="0" bIns="0" anchor="ctr"/>
+          <a:lstStyle/>
+          <a:p>
+            <a:pPr/>
+            <a:r>
+              <a:rPr sz="6900">
                 <a:solidFill>
                   <a:srgbClr val="FFFFFF"/>
                 </a:solidFill>
-                <a:latin typeface="DM Sans"/>
-                <a:ea typeface="DM Sans"/>
-              </a:rPr>
-              <a:t>CHALLENGE </a:t>
-            </a:r>
-            <a:pPr/>
-            <a:r>
-              <a:rPr sz="5700" b="1" spc="-75" kern="0">
-                <a:solidFill>
-                  <a:srgbClr val="FFD966"/>
-                </a:solidFill>
-                <a:latin typeface="DM Sans"/>
-                <a:ea typeface="DM Sans"/>
-              </a:rPr>
-              <a:t>STAGE</a:t>
-            </a:r>
-          </a:p>
-        </p:txBody>
-      </p:sp>
-      <p:sp>
-        <p:nvSpPr>
-          <p:cNvPr id="12" name=""/>
-          <p:cNvSpPr/>
-          <p:nvPr/>
-        </p:nvSpPr>
-        <p:spPr>
-          <a:xfrm>
-            <a:off x="609600" y="2895600"/>
+                <a:latin typeface="Reggae One"/>
+                <a:ea typeface="Reggae One"/>
+              </a:rPr>
+              <a:t>チャレンジステージ</a:t>
+            </a:r>
+          </a:p>
+        </p:txBody>
+      </p:sp>
+      <p:sp>
+        <p:nvSpPr>
+          <p:cNvPr id="13" name=""/>
+          <p:cNvSpPr/>
+          <p:nvPr/>
+        </p:nvSpPr>
+        <p:spPr>
+          <a:xfrm>
+            <a:off x="609600" y="3067050"/>
             <a:ext cx="7658100" cy="2114550"/>
           </a:xfrm>
           <a:prstGeom prst="roundRect">
@@ -46059,13 +45638,13 @@
       </p:sp>
       <p:sp>
         <p:nvSpPr>
-          <p:cNvPr id="13" name=""/>
-          <p:cNvSpPr txBox="1"/>
-          <p:nvPr/>
-        </p:nvSpPr>
-        <p:spPr>
-          <a:xfrm>
-            <a:off x="933450" y="3105150"/>
+          <p:cNvPr id="14" name=""/>
+          <p:cNvSpPr txBox="1"/>
+          <p:nvPr/>
+        </p:nvSpPr>
+        <p:spPr>
+          <a:xfrm>
+            <a:off x="933450" y="3276600"/>
             <a:ext cx="1362075" cy="171450"/>
           </a:xfrm>
           <a:prstGeom prst="rect">
@@ -46094,13 +45673,13 @@
       </p:sp>
       <p:sp>
         <p:nvSpPr>
-          <p:cNvPr id="14" name=""/>
-          <p:cNvSpPr txBox="1"/>
-          <p:nvPr/>
-        </p:nvSpPr>
-        <p:spPr>
-          <a:xfrm>
-            <a:off x="933450" y="3333750"/>
+          <p:cNvPr id="15" name=""/>
+          <p:cNvSpPr txBox="1"/>
+          <p:nvPr/>
+        </p:nvSpPr>
+        <p:spPr>
+          <a:xfrm>
+            <a:off x="933450" y="3505200"/>
             <a:ext cx="6438900" cy="523875"/>
           </a:xfrm>
           <a:prstGeom prst="rect">
@@ -46151,13 +45730,13 @@
       </p:sp>
       <p:sp>
         <p:nvSpPr>
-          <p:cNvPr id="15" name=""/>
-          <p:cNvSpPr txBox="1"/>
-          <p:nvPr/>
-        </p:nvSpPr>
-        <p:spPr>
-          <a:xfrm>
-            <a:off x="933450" y="3876675"/>
+          <p:cNvPr id="16" name=""/>
+          <p:cNvSpPr txBox="1"/>
+          <p:nvPr/>
+        </p:nvSpPr>
+        <p:spPr>
+          <a:xfrm>
+            <a:off x="933450" y="4048125"/>
             <a:ext cx="2095500" cy="276225"/>
           </a:xfrm>
           <a:prstGeom prst="rect">
@@ -46186,13 +45765,13 @@
       </p:sp>
       <p:sp>
         <p:nvSpPr>
-          <p:cNvPr id="16" name=""/>
-          <p:cNvSpPr txBox="1"/>
-          <p:nvPr/>
-        </p:nvSpPr>
-        <p:spPr>
-          <a:xfrm>
-            <a:off x="933450" y="4333875"/>
+          <p:cNvPr id="17" name=""/>
+          <p:cNvSpPr txBox="1"/>
+          <p:nvPr/>
+        </p:nvSpPr>
+        <p:spPr>
+          <a:xfrm>
+            <a:off x="933450" y="4505325"/>
             <a:ext cx="3181350" cy="428625"/>
           </a:xfrm>
           <a:prstGeom prst="rect">
@@ -46243,13 +45822,13 @@
       </p:sp>
       <p:sp>
         <p:nvSpPr>
-          <p:cNvPr id="17" name=""/>
-          <p:cNvSpPr/>
-          <p:nvPr/>
-        </p:nvSpPr>
-        <p:spPr>
-          <a:xfrm>
-            <a:off x="8867775" y="2667000"/>
+          <p:cNvPr id="18" name=""/>
+          <p:cNvSpPr/>
+          <p:nvPr/>
+        </p:nvSpPr>
+        <p:spPr>
+          <a:xfrm>
+            <a:off x="8867775" y="2838450"/>
             <a:ext cx="2571750" cy="2571750"/>
           </a:xfrm>
           <a:prstGeom prst="ellipse">
@@ -46260,7 +45839,7 @@
           </a:solidFill>
           <a:ln w="171450">
             <a:solidFill>
-              <a:srgbClr val="FFD966"/>
+              <a:srgbClr val="FFD3C2"/>
             </a:solidFill>
             <a:prstDash val="solid"/>
           </a:ln>
@@ -46275,13 +45854,13 @@
       </p:sp>
       <p:sp>
         <p:nvSpPr>
-          <p:cNvPr id="18" name=""/>
-          <p:cNvSpPr txBox="1"/>
-          <p:nvPr/>
-        </p:nvSpPr>
-        <p:spPr>
-          <a:xfrm>
-            <a:off x="9382125" y="3286125"/>
+          <p:cNvPr id="19" name=""/>
+          <p:cNvSpPr txBox="1"/>
+          <p:nvPr/>
+        </p:nvSpPr>
+        <p:spPr>
+          <a:xfrm>
+            <a:off x="9382125" y="3457575"/>
             <a:ext cx="2124075" cy="1038225"/>
           </a:xfrm>
           <a:prstGeom prst="rect">
@@ -46310,13 +45889,13 @@
       </p:sp>
       <p:sp>
         <p:nvSpPr>
-          <p:cNvPr id="19" name=""/>
-          <p:cNvSpPr txBox="1"/>
-          <p:nvPr/>
-        </p:nvSpPr>
-        <p:spPr>
-          <a:xfrm>
-            <a:off x="9725025" y="4305300"/>
+          <p:cNvPr id="20" name=""/>
+          <p:cNvSpPr txBox="1"/>
+          <p:nvPr/>
+        </p:nvSpPr>
+        <p:spPr>
+          <a:xfrm>
+            <a:off x="9725025" y="4476750"/>
             <a:ext cx="1323975" cy="190500"/>
           </a:xfrm>
           <a:prstGeom prst="rect">
@@ -46345,7 +45924,7 @@
       </p:sp>
       <p:sp>
         <p:nvSpPr>
-          <p:cNvPr id="20" name=""/>
+          <p:cNvPr id="21" name=""/>
           <p:cNvSpPr/>
           <p:nvPr/>
         </p:nvSpPr>
@@ -46367,7 +45946,7 @@
       </p:sp>
       <p:sp>
         <p:nvSpPr>
-          <p:cNvPr id="21" name=""/>
+          <p:cNvPr id="22" name=""/>
           <p:cNvSpPr/>
           <p:nvPr/>
         </p:nvSpPr>
@@ -46380,14 +45959,14 @@
             <a:avLst/>
           </a:prstGeom>
           <a:solidFill>
-            <a:srgbClr val="FFD966"/>
-          </a:solidFill>
-          <a:ln/>
-        </p:spPr>
-      </p:sp>
-      <p:sp>
-        <p:nvSpPr>
-          <p:cNvPr id="22" name=""/>
+            <a:srgbClr val="F0521E"/>
+          </a:solidFill>
+          <a:ln/>
+        </p:spPr>
+      </p:sp>
+      <p:sp>
+        <p:nvSpPr>
+          <p:cNvPr id="23" name=""/>
           <p:cNvSpPr txBox="1"/>
           <p:nvPr/>
         </p:nvSpPr>
@@ -46410,7 +45989,7 @@
             <a:r>
               <a:rPr sz="1350" b="1">
                 <a:solidFill>
-                  <a:srgbClr val="1A2238"/>
+                  <a:srgbClr val="FFFFFF"/>
                 </a:solidFill>
                 <a:latin typeface="DM Sans"/>
                 <a:ea typeface="DM Sans"/>
@@ -46422,7 +46001,7 @@
       </p:sp>
       <p:sp>
         <p:nvSpPr>
-          <p:cNvPr id="23" name=""/>
+          <p:cNvPr id="24" name=""/>
           <p:cNvSpPr txBox="1"/>
           <p:nvPr/>
         </p:nvSpPr>
@@ -46457,7 +46036,7 @@
       </p:sp>
       <p:sp>
         <p:nvSpPr>
-          <p:cNvPr id="24" name=""/>
+          <p:cNvPr id="25" name=""/>
           <p:cNvSpPr/>
           <p:nvPr/>
         </p:nvSpPr>
@@ -46479,7 +46058,7 @@
       </p:sp>
       <p:sp>
         <p:nvSpPr>
-          <p:cNvPr id="25" name=""/>
+          <p:cNvPr id="26" name=""/>
           <p:cNvSpPr/>
           <p:nvPr/>
         </p:nvSpPr>
@@ -46492,14 +46071,14 @@
             <a:avLst/>
           </a:prstGeom>
           <a:solidFill>
-            <a:srgbClr val="FFD966"/>
-          </a:solidFill>
-          <a:ln/>
-        </p:spPr>
-      </p:sp>
-      <p:sp>
-        <p:nvSpPr>
-          <p:cNvPr id="26" name=""/>
+            <a:srgbClr val="F0521E"/>
+          </a:solidFill>
+          <a:ln/>
+        </p:spPr>
+      </p:sp>
+      <p:sp>
+        <p:nvSpPr>
+          <p:cNvPr id="27" name=""/>
           <p:cNvSpPr txBox="1"/>
           <p:nvPr/>
         </p:nvSpPr>
@@ -46522,7 +46101,7 @@
             <a:r>
               <a:rPr sz="1350" b="1">
                 <a:solidFill>
-                  <a:srgbClr val="1A2238"/>
+                  <a:srgbClr val="FFFFFF"/>
                 </a:solidFill>
                 <a:latin typeface="DM Sans"/>
                 <a:ea typeface="DM Sans"/>
@@ -46534,7 +46113,7 @@
       </p:sp>
       <p:sp>
         <p:nvSpPr>
-          <p:cNvPr id="27" name=""/>
+          <p:cNvPr id="28" name=""/>
           <p:cNvSpPr txBox="1"/>
           <p:nvPr/>
         </p:nvSpPr>
@@ -46569,7 +46148,7 @@
       </p:sp>
       <p:sp>
         <p:nvSpPr>
-          <p:cNvPr id="28" name=""/>
+          <p:cNvPr id="29" name=""/>
           <p:cNvSpPr/>
           <p:nvPr/>
         </p:nvSpPr>
@@ -46591,7 +46170,7 @@
       </p:sp>
       <p:sp>
         <p:nvSpPr>
-          <p:cNvPr id="29" name=""/>
+          <p:cNvPr id="30" name=""/>
           <p:cNvSpPr/>
           <p:nvPr/>
         </p:nvSpPr>
@@ -46604,14 +46183,14 @@
             <a:avLst/>
           </a:prstGeom>
           <a:solidFill>
-            <a:srgbClr val="FFD966"/>
-          </a:solidFill>
-          <a:ln/>
-        </p:spPr>
-      </p:sp>
-      <p:sp>
-        <p:nvSpPr>
-          <p:cNvPr id="30" name=""/>
+            <a:srgbClr val="F0521E"/>
+          </a:solidFill>
+          <a:ln/>
+        </p:spPr>
+      </p:sp>
+      <p:sp>
+        <p:nvSpPr>
+          <p:cNvPr id="31" name=""/>
           <p:cNvSpPr txBox="1"/>
           <p:nvPr/>
         </p:nvSpPr>
@@ -46634,7 +46213,7 @@
             <a:r>
               <a:rPr sz="1350" b="1">
                 <a:solidFill>
-                  <a:srgbClr val="1A2238"/>
+                  <a:srgbClr val="FFFFFF"/>
                 </a:solidFill>
                 <a:latin typeface="DM Sans"/>
                 <a:ea typeface="DM Sans"/>
@@ -46646,7 +46225,7 @@
       </p:sp>
       <p:sp>
         <p:nvSpPr>
-          <p:cNvPr id="31" name=""/>
+          <p:cNvPr id="32" name=""/>
           <p:cNvSpPr txBox="1"/>
           <p:nvPr/>
         </p:nvSpPr>
@@ -46681,7 +46260,7 @@
       </p:sp>
       <p:sp>
         <p:nvSpPr>
-          <p:cNvPr id="32" name=""/>
+          <p:cNvPr id="33" name=""/>
           <p:cNvSpPr/>
           <p:nvPr/>
         </p:nvSpPr>
@@ -46722,7 +46301,7 @@
       </p:sp>
       <p:sp>
         <p:nvSpPr>
-          <p:cNvPr id="33" name=""/>
+          <p:cNvPr id="34" name=""/>
           <p:cNvSpPr/>
           <p:nvPr/>
         </p:nvSpPr>
@@ -46763,7 +46342,7 @@
       </p:sp>
       <p:sp>
         <p:nvSpPr>
-          <p:cNvPr id="34" name=""/>
+          <p:cNvPr id="35" name=""/>
           <p:cNvSpPr/>
           <p:nvPr/>
         </p:nvSpPr>
@@ -46804,7 +46383,7 @@
       </p:sp>
       <p:sp>
         <p:nvSpPr>
-          <p:cNvPr id="35" name=""/>
+          <p:cNvPr id="36" name=""/>
           <p:cNvSpPr/>
           <p:nvPr/>
         </p:nvSpPr>
@@ -46839,280 +46418,6 @@
           </a:custGeom>
           <a:solidFill>
             <a:srgbClr val="F0521E"/>
-          </a:solidFill>
-          <a:ln/>
-        </p:spPr>
-      </p:sp>
-      <p:sp>
-        <p:nvSpPr>
-          <p:cNvPr id="36" name=""/>
-          <p:cNvSpPr/>
-          <p:nvPr/>
-        </p:nvSpPr>
-        <p:spPr>
-          <a:xfrm>
-            <a:off x="10715625" y="1371600"/>
-            <a:ext cx="466725" cy="447675"/>
-          </a:xfrm>
-          <a:custGeom>
-            <a:avLst/>
-            <a:gdLst/>
-            <a:ahLst/>
-            <a:cxnLst/>
-            <a:rect l="l" t="t" r="r" b="b"/>
-            <a:pathLst>
-              <a:path w="466725" h="447675">
-                <a:moveTo>
-                  <a:pt x="235268" y="0"/>
-                </a:moveTo>
-                <a:lnTo>
-                  <a:pt x="300990" y="157163"/>
-                </a:lnTo>
-                <a:lnTo>
-                  <a:pt x="470535" y="171450"/>
-                </a:lnTo>
-                <a:lnTo>
-                  <a:pt x="340995" y="281940"/>
-                </a:lnTo>
-                <a:lnTo>
-                  <a:pt x="381000" y="447675"/>
-                </a:lnTo>
-                <a:lnTo>
-                  <a:pt x="235268" y="359092"/>
-                </a:lnTo>
-                <a:lnTo>
-                  <a:pt x="89535" y="447675"/>
-                </a:lnTo>
-                <a:lnTo>
-                  <a:pt x="129540" y="281940"/>
-                </a:lnTo>
-                <a:lnTo>
-                  <a:pt x="0" y="171450"/>
-                </a:lnTo>
-                <a:lnTo>
-                  <a:pt x="169545" y="157163"/>
-                </a:lnTo>
-                <a:close/>
-              </a:path>
-            </a:pathLst>
-          </a:custGeom>
-          <a:solidFill>
-            <a:srgbClr val="FFD966"/>
-          </a:solidFill>
-          <a:ln/>
-        </p:spPr>
-      </p:sp>
-      <p:sp>
-        <p:nvSpPr>
-          <p:cNvPr id="37" name=""/>
-          <p:cNvSpPr/>
-          <p:nvPr/>
-        </p:nvSpPr>
-        <p:spPr>
-          <a:xfrm>
-            <a:off x="8058150" y="2371725"/>
-            <a:ext cx="238125" cy="228600"/>
-          </a:xfrm>
-          <a:custGeom>
-            <a:avLst/>
-            <a:gdLst/>
-            <a:ahLst/>
-            <a:cxnLst/>
-            <a:rect l="l" t="t" r="r" b="b"/>
-            <a:pathLst>
-              <a:path w="238125" h="228600">
-                <a:moveTo>
-                  <a:pt x="118110" y="0"/>
-                </a:moveTo>
-                <a:lnTo>
-                  <a:pt x="150495" y="79058"/>
-                </a:lnTo>
-                <a:lnTo>
-                  <a:pt x="236220" y="85725"/>
-                </a:lnTo>
-                <a:lnTo>
-                  <a:pt x="171450" y="140970"/>
-                </a:lnTo>
-                <a:lnTo>
-                  <a:pt x="190500" y="223838"/>
-                </a:lnTo>
-                <a:lnTo>
-                  <a:pt x="118110" y="180022"/>
-                </a:lnTo>
-                <a:lnTo>
-                  <a:pt x="45720" y="223838"/>
-                </a:lnTo>
-                <a:lnTo>
-                  <a:pt x="64770" y="140970"/>
-                </a:lnTo>
-                <a:lnTo>
-                  <a:pt x="0" y="85725"/>
-                </a:lnTo>
-                <a:lnTo>
-                  <a:pt x="85725" y="79058"/>
-                </a:lnTo>
-                <a:close/>
-              </a:path>
-            </a:pathLst>
-          </a:custGeom>
-          <a:solidFill>
-            <a:srgbClr val="FFD966"/>
-          </a:solidFill>
-          <a:ln/>
-        </p:spPr>
-      </p:sp>
-      <p:sp>
-        <p:nvSpPr>
-          <p:cNvPr id="38" name=""/>
-          <p:cNvSpPr/>
-          <p:nvPr/>
-        </p:nvSpPr>
-        <p:spPr>
-          <a:xfrm>
-            <a:off x="8258175" y="1247775"/>
-            <a:ext cx="323850" cy="323850"/>
-          </a:xfrm>
-          <a:custGeom>
-            <a:avLst/>
-            <a:gdLst/>
-            <a:ahLst/>
-            <a:cxnLst/>
-            <a:rect l="l" t="t" r="r" b="b"/>
-            <a:pathLst>
-              <a:path w="323850" h="323850">
-                <a:moveTo>
-                  <a:pt x="161925" y="0"/>
-                </a:moveTo>
-                <a:cubicBezTo>
-                  <a:pt x="184785" y="139065"/>
-                  <a:pt x="184785" y="139065"/>
-                  <a:pt x="323850" y="161925"/>
-                </a:cubicBezTo>
-                <a:cubicBezTo>
-                  <a:pt x="184785" y="184785"/>
-                  <a:pt x="184785" y="184785"/>
-                  <a:pt x="161925" y="323850"/>
-                </a:cubicBezTo>
-                <a:cubicBezTo>
-                  <a:pt x="139065" y="184785"/>
-                  <a:pt x="139065" y="184785"/>
-                  <a:pt x="0" y="161925"/>
-                </a:cubicBezTo>
-                <a:cubicBezTo>
-                  <a:pt x="139065" y="139065"/>
-                  <a:pt x="139065" y="139065"/>
-                  <a:pt x="161925" y="0"/>
-                </a:cubicBezTo>
-                <a:close/>
-              </a:path>
-            </a:pathLst>
-          </a:custGeom>
-          <a:solidFill>
-            <a:srgbClr val="FFFFFF"/>
-          </a:solidFill>
-          <a:ln/>
-        </p:spPr>
-      </p:sp>
-      <p:sp>
-        <p:nvSpPr>
-          <p:cNvPr id="39" name=""/>
-          <p:cNvSpPr/>
-          <p:nvPr/>
-        </p:nvSpPr>
-        <p:spPr>
-          <a:xfrm>
-            <a:off x="11696700" y="2552700"/>
-            <a:ext cx="228600" cy="228600"/>
-          </a:xfrm>
-          <a:custGeom>
-            <a:avLst/>
-            <a:gdLst/>
-            <a:ahLst/>
-            <a:cxnLst/>
-            <a:rect l="l" t="t" r="r" b="b"/>
-            <a:pathLst>
-              <a:path w="228600" h="228600">
-                <a:moveTo>
-                  <a:pt x="114300" y="0"/>
-                </a:moveTo>
-                <a:cubicBezTo>
-                  <a:pt x="130493" y="98108"/>
-                  <a:pt x="130493" y="98108"/>
-                  <a:pt x="228600" y="114300"/>
-                </a:cubicBezTo>
-                <a:cubicBezTo>
-                  <a:pt x="130493" y="130492"/>
-                  <a:pt x="130493" y="130492"/>
-                  <a:pt x="114300" y="228600"/>
-                </a:cubicBezTo>
-                <a:cubicBezTo>
-                  <a:pt x="98107" y="130492"/>
-                  <a:pt x="98107" y="130492"/>
-                  <a:pt x="0" y="114300"/>
-                </a:cubicBezTo>
-                <a:cubicBezTo>
-                  <a:pt x="98107" y="98108"/>
-                  <a:pt x="98107" y="98108"/>
-                  <a:pt x="114300" y="0"/>
-                </a:cubicBezTo>
-                <a:close/>
-              </a:path>
-            </a:pathLst>
-          </a:custGeom>
-          <a:solidFill>
-            <a:srgbClr val="FFFFFF"/>
-          </a:solidFill>
-          <a:ln/>
-        </p:spPr>
-      </p:sp>
-      <p:sp>
-        <p:nvSpPr>
-          <p:cNvPr id="40" name=""/>
-          <p:cNvSpPr/>
-          <p:nvPr/>
-        </p:nvSpPr>
-        <p:spPr>
-          <a:xfrm>
-            <a:off x="7219950" y="5219700"/>
-            <a:ext cx="228600" cy="228600"/>
-          </a:xfrm>
-          <a:custGeom>
-            <a:avLst/>
-            <a:gdLst/>
-            <a:ahLst/>
-            <a:cxnLst/>
-            <a:rect l="l" t="t" r="r" b="b"/>
-            <a:pathLst>
-              <a:path w="228600" h="228600">
-                <a:moveTo>
-                  <a:pt x="114300" y="0"/>
-                </a:moveTo>
-                <a:cubicBezTo>
-                  <a:pt x="130493" y="98107"/>
-                  <a:pt x="130493" y="98107"/>
-                  <a:pt x="228600" y="114300"/>
-                </a:cubicBezTo>
-                <a:cubicBezTo>
-                  <a:pt x="130493" y="130493"/>
-                  <a:pt x="130493" y="130493"/>
-                  <a:pt x="114300" y="228600"/>
-                </a:cubicBezTo>
-                <a:cubicBezTo>
-                  <a:pt x="98107" y="130493"/>
-                  <a:pt x="98107" y="130493"/>
-                  <a:pt x="0" y="114300"/>
-                </a:cubicBezTo>
-                <a:cubicBezTo>
-                  <a:pt x="98107" y="98107"/>
-                  <a:pt x="98107" y="98107"/>
-                  <a:pt x="114300" y="0"/>
-                </a:cubicBezTo>
-                <a:close/>
-              </a:path>
-            </a:pathLst>
-          </a:custGeom>
-          <a:solidFill>
-            <a:srgbClr val="FFD966"/>
           </a:solidFill>
           <a:ln/>
         </p:spPr>

</xml_diff>

<commit_message>
Scott live: this weekend instead of next weekend, Christmas instead of お正月
Challenge round 2 asks "What will you do this weekend?" (今週末なにするの？),
the 瞬間英作文 questions say 今週末は instead of 週末なら / 週末は, and お正月
becomes クリスマス (the talk-time card and the last mixed question, now
"over Christmas").

Co-Authored-By: Claude Opus 5.5 <noreply@anthropic.com>
Claude-Session: https://claude.ai/code/session_0167kk19fU69KXrDnUiK9iq6
</commit_message>
<xml_diff>
--- a/live/scott-will-can/scott-will-can.pptx
+++ b/live/scott-will-can/scott-will-can.pptx
@@ -1766,7 +1766,7 @@
         <p:spPr>
           <a:xfrm>
             <a:off x="4657725" y="4524375"/>
-            <a:ext cx="2771775" cy="371475"/>
+            <a:ext cx="2657475" cy="371475"/>
           </a:xfrm>
           <a:prstGeom prst="rect">
             <a:avLst/>
@@ -1787,7 +1787,7 @@
                 <a:latin typeface="DM Sans"/>
                 <a:ea typeface="DM Sans"/>
               </a:rPr>
-              <a:t>next weekend?</a:t>
+              <a:t>this weekend?</a:t>
             </a:r>
           </a:p>
         </p:txBody>
@@ -1822,7 +1822,7 @@
                 <a:latin typeface="Noto Sans JP"/>
                 <a:ea typeface="Noto Sans JP"/>
               </a:rPr>
-              <a:t>来週末なにするの？</a:t>
+              <a:t>今週末なにするの？</a:t>
             </a:r>
           </a:p>
         </p:txBody>
@@ -3804,7 +3804,7 @@
         <p:spPr>
           <a:xfrm>
             <a:off x="933450" y="3524250"/>
-            <a:ext cx="7343775" cy="523875"/>
+            <a:ext cx="7191375" cy="523875"/>
           </a:xfrm>
           <a:prstGeom prst="rect">
             <a:avLst/>
@@ -3847,7 +3847,7 @@
                 <a:latin typeface="DM Sans"/>
                 <a:ea typeface="DM Sans"/>
               </a:rPr>
-              <a:t> you do next weekend?</a:t>
+              <a:t> you do this weekend?</a:t>
             </a:r>
           </a:p>
         </p:txBody>
@@ -3882,7 +3882,7 @@
                 <a:latin typeface="Noto Sans JP"/>
                 <a:ea typeface="Noto Sans JP"/>
               </a:rPr>
-              <a:t>来週末なにするの？</a:t>
+              <a:t>今週末なにするの？</a:t>
             </a:r>
           </a:p>
         </p:txBody>
@@ -6211,7 +6211,7 @@
         <p:spPr>
           <a:xfrm>
             <a:off x="4657725" y="4133850"/>
-            <a:ext cx="1390650" cy="438150"/>
+            <a:ext cx="2085975" cy="438150"/>
           </a:xfrm>
           <a:prstGeom prst="rect">
             <a:avLst/>
@@ -6232,7 +6232,7 @@
                 <a:latin typeface="Noto Sans JP"/>
                 <a:ea typeface="Noto Sans JP"/>
               </a:rPr>
-              <a:t>お正月</a:t>
+              <a:t>クリスマス</a:t>
             </a:r>
           </a:p>
         </p:txBody>
@@ -6246,7 +6246,7 @@
         <p:spPr>
           <a:xfrm>
             <a:off x="4657725" y="4705350"/>
-            <a:ext cx="2333625" cy="238125"/>
+            <a:ext cx="2295525" cy="238125"/>
           </a:xfrm>
           <a:prstGeom prst="rect">
             <a:avLst/>
@@ -6267,7 +6267,7 @@
                 <a:latin typeface="DM Sans"/>
                 <a:ea typeface="DM Sans"/>
               </a:rPr>
-              <a:t>New Year's in Japan</a:t>
+              <a:t>Christmas in Japan</a:t>
             </a:r>
           </a:p>
         </p:txBody>
@@ -11938,7 +11938,7 @@
                 <a:latin typeface="Noto Sans JP"/>
                 <a:ea typeface="Noto Sans JP"/>
               </a:rPr>
-              <a:t>週末なら家族とキャンプに行けるよ</a:t>
+              <a:t>今週末は家族とキャンプに行けるよ</a:t>
             </a:r>
           </a:p>
         </p:txBody>
@@ -12232,7 +12232,7 @@
                 <a:latin typeface="Noto Sans JP"/>
                 <a:ea typeface="Noto Sans JP"/>
               </a:rPr>
-              <a:t>週末なら家族とキャンプに行けるよ</a:t>
+              <a:t>今週末は家族とキャンプに行けるよ</a:t>
             </a:r>
           </a:p>
         </p:txBody>
@@ -16415,8 +16415,8 @@
         </p:nvSpPr>
         <p:spPr>
           <a:xfrm>
-            <a:off x="3238500" y="3581400"/>
-            <a:ext cx="6915150" cy="828675"/>
+            <a:off x="2952750" y="3581400"/>
+            <a:ext cx="7572375" cy="828675"/>
           </a:xfrm>
           <a:prstGeom prst="rect">
             <a:avLst/>
@@ -16437,7 +16437,7 @@
                 <a:latin typeface="Noto Sans JP"/>
                 <a:ea typeface="Noto Sans JP"/>
               </a:rPr>
-              <a:t>週末は妹と海に行くよ</a:t>
+              <a:t>今週末は妹と海に行くよ</a:t>
             </a:r>
           </a:p>
         </p:txBody>
@@ -16709,8 +16709,8 @@
         </p:nvSpPr>
         <p:spPr>
           <a:xfrm>
-            <a:off x="5048250" y="3181350"/>
-            <a:ext cx="2752725" cy="304800"/>
+            <a:off x="4943475" y="3181350"/>
+            <a:ext cx="2990850" cy="304800"/>
           </a:xfrm>
           <a:prstGeom prst="rect">
             <a:avLst/>
@@ -16731,7 +16731,7 @@
                 <a:latin typeface="Noto Sans JP"/>
                 <a:ea typeface="Noto Sans JP"/>
               </a:rPr>
-              <a:t>週末は妹と海に行くよ</a:t>
+              <a:t>今週末は妹と海に行くよ</a:t>
             </a:r>
           </a:p>
         </p:txBody>
@@ -21888,8 +21888,8 @@
         </p:nvSpPr>
         <p:spPr>
           <a:xfrm>
-            <a:off x="1762125" y="3581400"/>
-            <a:ext cx="10315575" cy="828675"/>
+            <a:off x="1476375" y="3581400"/>
+            <a:ext cx="10972800" cy="828675"/>
           </a:xfrm>
           <a:prstGeom prst="rect">
             <a:avLst/>
@@ -21910,7 +21910,7 @@
                 <a:latin typeface="Noto Sans JP"/>
                 <a:ea typeface="Noto Sans JP"/>
               </a:rPr>
-              <a:t>週末は友達とビーチでBBQするよ</a:t>
+              <a:t>今週末は友達とビーチでBBQするよ</a:t>
             </a:r>
           </a:p>
         </p:txBody>
@@ -22182,8 +22182,8 @@
         </p:nvSpPr>
         <p:spPr>
           <a:xfrm>
-            <a:off x="4514850" y="3181350"/>
-            <a:ext cx="3990975" cy="304800"/>
+            <a:off x="4410075" y="3181350"/>
+            <a:ext cx="4229100" cy="304800"/>
           </a:xfrm>
           <a:prstGeom prst="rect">
             <a:avLst/>
@@ -22204,7 +22204,7 @@
                 <a:latin typeface="Noto Sans JP"/>
                 <a:ea typeface="Noto Sans JP"/>
               </a:rPr>
-              <a:t>週末は友達とビーチでBBQするよ</a:t>
+              <a:t>今週末は友達とビーチでBBQするよ</a:t>
             </a:r>
           </a:p>
         </p:txBody>
@@ -22590,8 +22590,8 @@
         </p:nvSpPr>
         <p:spPr>
           <a:xfrm>
-            <a:off x="2095500" y="3581400"/>
-            <a:ext cx="9544050" cy="828675"/>
+            <a:off x="1533525" y="3581400"/>
+            <a:ext cx="10839450" cy="828675"/>
           </a:xfrm>
           <a:prstGeom prst="rect">
             <a:avLst/>
@@ -22612,7 +22612,7 @@
                 <a:latin typeface="Noto Sans JP"/>
                 <a:ea typeface="Noto Sans JP"/>
               </a:rPr>
-              <a:t>お正月は実家でのんびりするよ</a:t>
+              <a:t>クリスマスは実家でのんびりするよ</a:t>
             </a:r>
           </a:p>
         </p:txBody>
@@ -23921,8 +23921,8 @@
         </p:nvSpPr>
         <p:spPr>
           <a:xfrm>
-            <a:off x="4629150" y="3181350"/>
-            <a:ext cx="3714750" cy="304800"/>
+            <a:off x="4419600" y="3181350"/>
+            <a:ext cx="4191000" cy="304800"/>
           </a:xfrm>
           <a:prstGeom prst="rect">
             <a:avLst/>
@@ -23943,7 +23943,7 @@
                 <a:latin typeface="Noto Sans JP"/>
                 <a:ea typeface="Noto Sans JP"/>
               </a:rPr>
-              <a:t>お正月は実家でのんびりするよ</a:t>
+              <a:t>クリスマスは実家でのんびりするよ</a:t>
             </a:r>
           </a:p>
         </p:txBody>
@@ -24024,8 +24024,8 @@
         </p:nvSpPr>
         <p:spPr>
           <a:xfrm>
-            <a:off x="3905250" y="4181475"/>
-            <a:ext cx="4371975" cy="600075"/>
+            <a:off x="3952875" y="4181475"/>
+            <a:ext cx="4276725" cy="600075"/>
           </a:xfrm>
           <a:prstGeom prst="rect">
             <a:avLst/>
@@ -24046,7 +24046,7 @@
                 <a:latin typeface="DM Sans"/>
                 <a:ea typeface="DM Sans"/>
               </a:rPr>
-              <a:t>over New Year's.</a:t>
+              <a:t>over Christmas.</a:t>
             </a:r>
           </a:p>
         </p:txBody>

</xml_diff>